<commit_message>
Deck: designer-panel fixes (cover stat, per-vehicle brief, alternatives, legible architecture, cost levers)
Co-Authored-By: Claude Sonnet 5.5 <noreply@anthropic.com>
</commit_message>
<xml_diff>
--- a/deck/Green-Corridor-Deck.pptx
+++ b/deck/Green-Corridor-Deck.pptx
@@ -3306,47 +3306,131 @@
                 <a:ea typeface="Arial"/>
                 <a:cs typeface="Arial"/>
               </a:rPr>
-              <a:t>Team Green Corridor · Nandish · green-corridor-2026.web.app</a:t>
-            </a:r>
-          </a:p>
-        </p:txBody>
-      </p:sp>
-      <p:pic>
-        <p:nvPicPr>
-          <p:cNvPr id="7" name="Screenshot" descr="image.jpg"/>
-          <p:cNvPicPr>
-            <a:picLocks noChangeAspect="1"/>
-          </p:cNvPicPr>
-          <p:nvPr/>
-        </p:nvPicPr>
-        <p:blipFill>
-          <a:blip r:embed="rId2"/>
-          <a:stretch>
-            <a:fillRect/>
-          </a:stretch>
-        </p:blipFill>
-        <p:spPr>
-          <a:xfrm>
-            <a:off x="6583680" y="2697480"/>
-            <a:ext cx="4983480" cy="2804038"/>
+              <a:t>Nandish · green-corridor-2026.web.app</a:t>
+            </a:r>
+          </a:p>
+        </p:txBody>
+      </p:sp>
+      <p:sp>
+        <p:nvSpPr>
+          <p:cNvPr id="7" name="Cover stat"/>
+          <p:cNvSpPr/>
+          <p:nvPr/>
+        </p:nvSpPr>
+        <p:spPr>
+          <a:xfrm>
+            <a:off x="6812280" y="2286000"/>
+            <a:ext cx="4754880" cy="3017520"/>
+          </a:xfrm>
+          <a:prstGeom prst="roundRect">
+            <a:avLst>
+              <a:gd name="adj" fmla="val 4848"/>
+            </a:avLst>
+          </a:prstGeom>
+          <a:solidFill>
+            <a:srgbClr val="14171B"/>
+          </a:solidFill>
+          <a:ln>
+            <a:noFill/>
+          </a:ln>
+          <a:effectLst/>
+        </p:spPr>
+        <p:style>
+          <a:lnRef idx="1">
+            <a:schemeClr val="accent1"/>
+          </a:lnRef>
+          <a:fillRef idx="3">
+            <a:schemeClr val="accent1"/>
+          </a:fillRef>
+          <a:effectRef idx="2">
+            <a:schemeClr val="accent1"/>
+          </a:effectRef>
+          <a:fontRef idx="minor">
+            <a:schemeClr val="lt1"/>
+          </a:fontRef>
+        </p:style>
+        <p:txBody>
+          <a:bodyPr rtlCol="0" anchor="ctr" wrap="square" lIns="365760" tIns="182880" rIns="320040" bIns="182880"/>
+          <a:lstStyle/>
+          <a:p>
+            <a:pPr algn="l">
+              <a:spcAft>
+                <a:spcPts val="600"/>
+              </a:spcAft>
+            </a:pPr>
+            <a:r>
+              <a:rPr sz="7200" b="1">
+                <a:solidFill>
+                  <a:srgbClr val="F59E0B"/>
+                </a:solidFill>
+                <a:latin typeface="Arial"/>
+                <a:ea typeface="Arial"/>
+                <a:cs typeface="Arial"/>
+              </a:rPr>
+              <a:t>60 %+</a:t>
+            </a:r>
+          </a:p>
+          <a:p>
+            <a:pPr algn="l">
+              <a:spcAft>
+                <a:spcPts val="600"/>
+              </a:spcAft>
+            </a:pPr>
+            <a:r>
+              <a:rPr sz="1700" b="0">
+                <a:solidFill>
+                  <a:srgbClr val="E5E7EB"/>
+                </a:solidFill>
+                <a:latin typeface="Arial"/>
+                <a:ea typeface="Arial"/>
+                <a:cs typeface="Arial"/>
+              </a:rPr>
+              <a:t>of Karnataka 108 cardiac, stroke, respiratory calls missed the 10-minute target</a:t>
+            </a:r>
+          </a:p>
+        </p:txBody>
+      </p:sp>
+      <p:sp>
+        <p:nvSpPr>
+          <p:cNvPr id="8" name="Cover citation"/>
+          <p:cNvSpPr txBox="1"/>
+          <p:nvPr/>
+        </p:nvSpPr>
+        <p:spPr>
+          <a:xfrm>
+            <a:off x="6812280" y="5440680"/>
+            <a:ext cx="4754880" cy="548640"/>
           </a:xfrm>
           <a:prstGeom prst="rect">
             <a:avLst/>
           </a:prstGeom>
-          <a:ln w="9525">
-            <a:solidFill>
-              <a:srgbClr val="2B2D31"/>
-            </a:solidFill>
-          </a:ln>
-          <a:effectLst>
-            <a:outerShdw blurRad="152400" dist="38100" dir="5400000" algn="t" rotWithShape="0">
-              <a:srgbClr val="000000">
-                <a:alpha val="26000"/>
-              </a:srgbClr>
-            </a:outerShdw>
-          </a:effectLst>
-        </p:spPr>
-      </p:pic>
+          <a:noFill/>
+        </p:spPr>
+        <p:txBody>
+          <a:bodyPr wrap="square" anchor="t" lIns="0" tIns="0" rIns="0" bIns="0">
+            <a:spAutoFit/>
+          </a:bodyPr>
+          <a:lstStyle/>
+          <a:p>
+            <a:pPr algn="l">
+              <a:spcAft>
+                <a:spcPts val="0"/>
+              </a:spcAft>
+            </a:pPr>
+            <a:r>
+              <a:rPr sz="1100" b="0">
+                <a:solidFill>
+                  <a:srgbClr val="9CA3AF"/>
+                </a:solidFill>
+                <a:latin typeface="Arial"/>
+                <a:ea typeface="Arial"/>
+                <a:cs typeface="Arial"/>
+              </a:rPr>
+              <a:t>Source: CAG audit of Karnataka 108 EMS, 2014–19</a:t>
+            </a:r>
+          </a:p>
+        </p:txBody>
+      </p:sp>
     </p:spTree>
   </p:cSld>
   <p:clrMapOvr>
@@ -3616,654 +3700,18 @@
       </p:sp>
       <p:sp>
         <p:nvSpPr>
-          <p:cNvPr id="8" name="Cost cell"/>
-          <p:cNvSpPr txBox="1"/>
-          <p:nvPr/>
-        </p:nvSpPr>
-        <p:spPr>
-          <a:xfrm>
-            <a:off x="731519" y="2057400"/>
-            <a:ext cx="1554480" cy="777240"/>
-          </a:xfrm>
-          <a:prstGeom prst="rect">
-            <a:avLst/>
-          </a:prstGeom>
-          <a:noFill/>
-        </p:spPr>
-        <p:txBody>
-          <a:bodyPr wrap="square" anchor="ctr" lIns="0" tIns="0" rIns="0" bIns="0">
-            <a:spAutoFit/>
-          </a:bodyPr>
-          <a:lstStyle/>
-          <a:p>
-            <a:pPr algn="l">
-              <a:spcAft>
-                <a:spcPts val="0"/>
-              </a:spcAft>
-            </a:pPr>
-            <a:r>
-              <a:rPr sz="1600" b="1">
-                <a:solidFill>
-                  <a:srgbClr val="6B7280"/>
-                </a:solidFill>
-                <a:latin typeface="Arial"/>
-                <a:ea typeface="Arial"/>
-                <a:cs typeface="Arial"/>
-              </a:rPr>
-              <a:t>Service</a:t>
-            </a:r>
-          </a:p>
-        </p:txBody>
-      </p:sp>
-      <p:sp>
-        <p:nvSpPr>
-          <p:cNvPr id="9" name="Cost cell"/>
-          <p:cNvSpPr txBox="1"/>
-          <p:nvPr/>
-        </p:nvSpPr>
-        <p:spPr>
-          <a:xfrm>
-            <a:off x="2468879" y="2057400"/>
-            <a:ext cx="3200400" cy="777240"/>
-          </a:xfrm>
-          <a:prstGeom prst="rect">
-            <a:avLst/>
-          </a:prstGeom>
-          <a:noFill/>
-        </p:spPr>
-        <p:txBody>
-          <a:bodyPr wrap="square" anchor="ctr" lIns="0" tIns="0" rIns="0" bIns="0">
-            <a:spAutoFit/>
-          </a:bodyPr>
-          <a:lstStyle/>
-          <a:p>
-            <a:pPr algn="l">
-              <a:spcAft>
-                <a:spcPts val="0"/>
-              </a:spcAft>
-            </a:pPr>
-            <a:r>
-              <a:rPr sz="1600" b="1">
-                <a:solidFill>
-                  <a:srgbClr val="6B7280"/>
-                </a:solidFill>
-                <a:latin typeface="Arial"/>
-                <a:ea typeface="Arial"/>
-                <a:cs typeface="Arial"/>
-              </a:rPr>
-              <a:t>Basis</a:t>
-            </a:r>
-          </a:p>
-        </p:txBody>
-      </p:sp>
-      <p:sp>
-        <p:nvSpPr>
-          <p:cNvPr id="10" name="Cost cell"/>
-          <p:cNvSpPr txBox="1"/>
-          <p:nvPr/>
-        </p:nvSpPr>
-        <p:spPr>
-          <a:xfrm>
-            <a:off x="5852159" y="2057400"/>
-            <a:ext cx="1280160" cy="777240"/>
-          </a:xfrm>
-          <a:prstGeom prst="rect">
-            <a:avLst/>
-          </a:prstGeom>
-          <a:noFill/>
-        </p:spPr>
-        <p:txBody>
-          <a:bodyPr wrap="square" anchor="ctr" lIns="0" tIns="0" rIns="0" bIns="0">
-            <a:spAutoFit/>
-          </a:bodyPr>
-          <a:lstStyle/>
-          <a:p>
-            <a:pPr algn="r">
-              <a:spcAft>
-                <a:spcPts val="0"/>
-              </a:spcAft>
-            </a:pPr>
-            <a:r>
-              <a:rPr sz="1600" b="1">
-                <a:solidFill>
-                  <a:srgbClr val="6B7280"/>
-                </a:solidFill>
-                <a:latin typeface="Arial"/>
-                <a:ea typeface="Arial"/>
-                <a:cs typeface="Arial"/>
-              </a:rPr>
-              <a:t>₹ per hour</a:t>
-            </a:r>
-          </a:p>
-        </p:txBody>
-      </p:sp>
-      <p:cxnSp>
-        <p:nvCxnSpPr>
-          <p:cNvPr id="11" name="Connector"/>
-          <p:cNvCxnSpPr/>
-          <p:nvPr/>
-        </p:nvCxnSpPr>
-        <p:spPr>
-          <a:xfrm>
-            <a:off x="640080" y="2834640"/>
-            <a:ext cx="6583680" cy="0"/>
-          </a:xfrm>
-          <a:prstGeom prst="line">
-            <a:avLst/>
-          </a:prstGeom>
-          <a:ln w="9525">
-            <a:solidFill>
-              <a:srgbClr val="D9DADD"/>
-            </a:solidFill>
-          </a:ln>
-          <a:effectLst/>
-        </p:spPr>
-        <p:style>
-          <a:lnRef idx="2">
-            <a:schemeClr val="accent1"/>
-          </a:lnRef>
-          <a:fillRef idx="0">
-            <a:schemeClr val="accent1"/>
-          </a:fillRef>
-          <a:effectRef idx="1">
-            <a:schemeClr val="accent1"/>
-          </a:effectRef>
-          <a:fontRef idx="minor">
-            <a:schemeClr val="tx1"/>
-          </a:fontRef>
-        </p:style>
-      </p:cxnSp>
-      <p:sp>
-        <p:nvSpPr>
-          <p:cNvPr id="12" name="Cost cell"/>
-          <p:cNvSpPr txBox="1"/>
-          <p:nvPr/>
-        </p:nvSpPr>
-        <p:spPr>
-          <a:xfrm>
-            <a:off x="731519" y="2834640"/>
-            <a:ext cx="1554480" cy="777240"/>
-          </a:xfrm>
-          <a:prstGeom prst="rect">
-            <a:avLst/>
-          </a:prstGeom>
-          <a:noFill/>
-        </p:spPr>
-        <p:txBody>
-          <a:bodyPr wrap="square" anchor="ctr" lIns="0" tIns="0" rIns="0" bIns="0">
-            <a:spAutoFit/>
-          </a:bodyPr>
-          <a:lstStyle/>
-          <a:p>
-            <a:pPr algn="l">
-              <a:spcAft>
-                <a:spcPts val="0"/>
-              </a:spcAft>
-            </a:pPr>
-            <a:r>
-              <a:rPr sz="1600" b="1">
-                <a:solidFill>
-                  <a:srgbClr val="111111"/>
-                </a:solidFill>
-                <a:latin typeface="Arial"/>
-                <a:ea typeface="Arial"/>
-                <a:cs typeface="Arial"/>
-              </a:rPr>
-              <a:t>Routes</a:t>
-            </a:r>
-          </a:p>
-        </p:txBody>
-      </p:sp>
-      <p:sp>
-        <p:nvSpPr>
-          <p:cNvPr id="13" name="Cost cell"/>
-          <p:cNvSpPr txBox="1"/>
-          <p:nvPr/>
-        </p:nvSpPr>
-        <p:spPr>
-          <a:xfrm>
-            <a:off x="2468879" y="2834640"/>
-            <a:ext cx="3200400" cy="777240"/>
-          </a:xfrm>
-          <a:prstGeom prst="rect">
-            <a:avLst/>
-          </a:prstGeom>
-          <a:noFill/>
-        </p:spPr>
-        <p:txBody>
-          <a:bodyPr wrap="square" anchor="ctr" lIns="0" tIns="0" rIns="0" bIns="0">
-            <a:spAutoFit/>
-          </a:bodyPr>
-          <a:lstStyle/>
-          <a:p>
-            <a:pPr algn="l">
-              <a:spcAft>
-                <a:spcPts val="0"/>
-              </a:spcAft>
-            </a:pPr>
-            <a:r>
-              <a:rPr sz="1600" b="0">
-                <a:solidFill>
-                  <a:srgbClr val="111111"/>
-                </a:solidFill>
-                <a:latin typeface="Arial"/>
-                <a:ea typeface="Arial"/>
-                <a:cs typeface="Arial"/>
-              </a:rPr>
-              <a:t>3 calls/min × 60 × ₹0.85</a:t>
-            </a:r>
-          </a:p>
-        </p:txBody>
-      </p:sp>
-      <p:sp>
-        <p:nvSpPr>
-          <p:cNvPr id="14" name="Cost cell"/>
-          <p:cNvSpPr txBox="1"/>
-          <p:nvPr/>
-        </p:nvSpPr>
-        <p:spPr>
-          <a:xfrm>
-            <a:off x="5852159" y="2834640"/>
-            <a:ext cx="1280160" cy="777240"/>
-          </a:xfrm>
-          <a:prstGeom prst="rect">
-            <a:avLst/>
-          </a:prstGeom>
-          <a:noFill/>
-        </p:spPr>
-        <p:txBody>
-          <a:bodyPr wrap="square" anchor="ctr" lIns="0" tIns="0" rIns="0" bIns="0">
-            <a:spAutoFit/>
-          </a:bodyPr>
-          <a:lstStyle/>
-          <a:p>
-            <a:pPr algn="r">
-              <a:spcAft>
-                <a:spcPts val="0"/>
-              </a:spcAft>
-            </a:pPr>
-            <a:r>
-              <a:rPr sz="1600" b="0">
-                <a:solidFill>
-                  <a:srgbClr val="111111"/>
-                </a:solidFill>
-                <a:latin typeface="Arial"/>
-                <a:ea typeface="Arial"/>
-                <a:cs typeface="Arial"/>
-              </a:rPr>
-              <a:t>₹153</a:t>
-            </a:r>
-          </a:p>
-        </p:txBody>
-      </p:sp>
-      <p:cxnSp>
-        <p:nvCxnSpPr>
-          <p:cNvPr id="15" name="Connector"/>
-          <p:cNvCxnSpPr/>
-          <p:nvPr/>
-        </p:nvCxnSpPr>
-        <p:spPr>
-          <a:xfrm>
-            <a:off x="640080" y="3611880"/>
-            <a:ext cx="6583680" cy="0"/>
-          </a:xfrm>
-          <a:prstGeom prst="line">
-            <a:avLst/>
-          </a:prstGeom>
-          <a:ln w="9525">
-            <a:solidFill>
-              <a:srgbClr val="D9DADD"/>
-            </a:solidFill>
-          </a:ln>
-          <a:effectLst/>
-        </p:spPr>
-        <p:style>
-          <a:lnRef idx="2">
-            <a:schemeClr val="accent1"/>
-          </a:lnRef>
-          <a:fillRef idx="0">
-            <a:schemeClr val="accent1"/>
-          </a:fillRef>
-          <a:effectRef idx="1">
-            <a:schemeClr val="accent1"/>
-          </a:effectRef>
-          <a:fontRef idx="minor">
-            <a:schemeClr val="tx1"/>
-          </a:fontRef>
-        </p:style>
-      </p:cxnSp>
-      <p:sp>
-        <p:nvSpPr>
-          <p:cNvPr id="16" name="Cost cell"/>
-          <p:cNvSpPr txBox="1"/>
-          <p:nvPr/>
-        </p:nvSpPr>
-        <p:spPr>
-          <a:xfrm>
-            <a:off x="731519" y="3611880"/>
-            <a:ext cx="1554480" cy="777240"/>
-          </a:xfrm>
-          <a:prstGeom prst="rect">
-            <a:avLst/>
-          </a:prstGeom>
-          <a:noFill/>
-        </p:spPr>
-        <p:txBody>
-          <a:bodyPr wrap="square" anchor="ctr" lIns="0" tIns="0" rIns="0" bIns="0">
-            <a:spAutoFit/>
-          </a:bodyPr>
-          <a:lstStyle/>
-          <a:p>
-            <a:pPr algn="l">
-              <a:spcAft>
-                <a:spcPts val="0"/>
-              </a:spcAft>
-            </a:pPr>
-            <a:r>
-              <a:rPr sz="1600" b="1">
-                <a:solidFill>
-                  <a:srgbClr val="111111"/>
-                </a:solidFill>
-                <a:latin typeface="Arial"/>
-                <a:ea typeface="Arial"/>
-                <a:cs typeface="Arial"/>
-              </a:rPr>
-              <a:t>Gemini</a:t>
-            </a:r>
-          </a:p>
-        </p:txBody>
-      </p:sp>
-      <p:sp>
-        <p:nvSpPr>
-          <p:cNvPr id="17" name="Cost cell"/>
-          <p:cNvSpPr txBox="1"/>
-          <p:nvPr/>
-        </p:nvSpPr>
-        <p:spPr>
-          <a:xfrm>
-            <a:off x="2468879" y="3611880"/>
-            <a:ext cx="3200400" cy="777240"/>
-          </a:xfrm>
-          <a:prstGeom prst="rect">
-            <a:avLst/>
-          </a:prstGeom>
-          <a:noFill/>
-        </p:spPr>
-        <p:txBody>
-          <a:bodyPr wrap="square" anchor="ctr" lIns="0" tIns="0" rIns="0" bIns="0">
-            <a:spAutoFit/>
-          </a:bodyPr>
-          <a:lstStyle/>
-          <a:p>
-            <a:pPr algn="l">
-              <a:spcAft>
-                <a:spcPts val="0"/>
-              </a:spcAft>
-            </a:pPr>
-            <a:r>
-              <a:rPr sz="1600" b="0">
-                <a:solidFill>
-                  <a:srgbClr val="111111"/>
-                </a:solidFill>
-                <a:latin typeface="Arial"/>
-                <a:ea typeface="Arial"/>
-                <a:cs typeface="Arial"/>
-              </a:rPr>
-              <a:t>17 calls × ₹0.02</a:t>
-            </a:r>
-          </a:p>
-        </p:txBody>
-      </p:sp>
-      <p:sp>
-        <p:nvSpPr>
-          <p:cNvPr id="18" name="Cost cell"/>
-          <p:cNvSpPr txBox="1"/>
-          <p:nvPr/>
-        </p:nvSpPr>
-        <p:spPr>
-          <a:xfrm>
-            <a:off x="5852159" y="3611880"/>
-            <a:ext cx="1280160" cy="777240"/>
-          </a:xfrm>
-          <a:prstGeom prst="rect">
-            <a:avLst/>
-          </a:prstGeom>
-          <a:noFill/>
-        </p:spPr>
-        <p:txBody>
-          <a:bodyPr wrap="square" anchor="ctr" lIns="0" tIns="0" rIns="0" bIns="0">
-            <a:spAutoFit/>
-          </a:bodyPr>
-          <a:lstStyle/>
-          <a:p>
-            <a:pPr algn="r">
-              <a:spcAft>
-                <a:spcPts val="0"/>
-              </a:spcAft>
-            </a:pPr>
-            <a:r>
-              <a:rPr sz="1600" b="0">
-                <a:solidFill>
-                  <a:srgbClr val="111111"/>
-                </a:solidFill>
-                <a:latin typeface="Arial"/>
-                <a:ea typeface="Arial"/>
-                <a:cs typeface="Arial"/>
-              </a:rPr>
-              <a:t>₹0.34</a:t>
-            </a:r>
-          </a:p>
-        </p:txBody>
-      </p:sp>
-      <p:cxnSp>
-        <p:nvCxnSpPr>
-          <p:cNvPr id="19" name="Connector"/>
-          <p:cNvCxnSpPr/>
-          <p:nvPr/>
-        </p:nvCxnSpPr>
-        <p:spPr>
-          <a:xfrm>
-            <a:off x="640080" y="4389120"/>
-            <a:ext cx="6583680" cy="0"/>
-          </a:xfrm>
-          <a:prstGeom prst="line">
-            <a:avLst/>
-          </a:prstGeom>
-          <a:ln w="9525">
-            <a:solidFill>
-              <a:srgbClr val="D9DADD"/>
-            </a:solidFill>
-          </a:ln>
-          <a:effectLst/>
-        </p:spPr>
-        <p:style>
-          <a:lnRef idx="2">
-            <a:schemeClr val="accent1"/>
-          </a:lnRef>
-          <a:fillRef idx="0">
-            <a:schemeClr val="accent1"/>
-          </a:fillRef>
-          <a:effectRef idx="1">
-            <a:schemeClr val="accent1"/>
-          </a:effectRef>
-          <a:fontRef idx="minor">
-            <a:schemeClr val="tx1"/>
-          </a:fontRef>
-        </p:style>
-      </p:cxnSp>
-      <p:sp>
-        <p:nvSpPr>
-          <p:cNvPr id="20" name="Cost cell"/>
-          <p:cNvSpPr txBox="1"/>
-          <p:nvPr/>
-        </p:nvSpPr>
-        <p:spPr>
-          <a:xfrm>
-            <a:off x="731519" y="4389120"/>
-            <a:ext cx="1554480" cy="777240"/>
-          </a:xfrm>
-          <a:prstGeom prst="rect">
-            <a:avLst/>
-          </a:prstGeom>
-          <a:noFill/>
-        </p:spPr>
-        <p:txBody>
-          <a:bodyPr wrap="square" anchor="ctr" lIns="0" tIns="0" rIns="0" bIns="0">
-            <a:spAutoFit/>
-          </a:bodyPr>
-          <a:lstStyle/>
-          <a:p>
-            <a:pPr algn="l">
-              <a:spcAft>
-                <a:spcPts val="0"/>
-              </a:spcAft>
-            </a:pPr>
-            <a:r>
-              <a:rPr sz="1600" b="1">
-                <a:solidFill>
-                  <a:srgbClr val="111111"/>
-                </a:solidFill>
-                <a:latin typeface="Arial"/>
-                <a:ea typeface="Arial"/>
-                <a:cs typeface="Arial"/>
-              </a:rPr>
-              <a:t>Text-to-Speech</a:t>
-            </a:r>
-          </a:p>
-        </p:txBody>
-      </p:sp>
-      <p:sp>
-        <p:nvSpPr>
-          <p:cNvPr id="21" name="Cost cell"/>
-          <p:cNvSpPr txBox="1"/>
-          <p:nvPr/>
-        </p:nvSpPr>
-        <p:spPr>
-          <a:xfrm>
-            <a:off x="2468879" y="4389120"/>
-            <a:ext cx="3200400" cy="777240"/>
-          </a:xfrm>
-          <a:prstGeom prst="rect">
-            <a:avLst/>
-          </a:prstGeom>
-          <a:noFill/>
-        </p:spPr>
-        <p:txBody>
-          <a:bodyPr wrap="square" anchor="ctr" lIns="0" tIns="0" rIns="0" bIns="0">
-            <a:spAutoFit/>
-          </a:bodyPr>
-          <a:lstStyle/>
-          <a:p>
-            <a:pPr algn="l">
-              <a:spcAft>
-                <a:spcPts val="0"/>
-              </a:spcAft>
-            </a:pPr>
-            <a:r>
-              <a:rPr sz="1600" b="0">
-                <a:solidFill>
-                  <a:srgbClr val="111111"/>
-                </a:solidFill>
-                <a:latin typeface="Arial"/>
-                <a:ea typeface="Arial"/>
-                <a:cs typeface="Arial"/>
-              </a:rPr>
-              <a:t>~1,000 chars × ₹1.30/1,000</a:t>
-            </a:r>
-          </a:p>
-        </p:txBody>
-      </p:sp>
-      <p:sp>
-        <p:nvSpPr>
-          <p:cNvPr id="22" name="Cost cell"/>
-          <p:cNvSpPr txBox="1"/>
-          <p:nvPr/>
-        </p:nvSpPr>
-        <p:spPr>
-          <a:xfrm>
-            <a:off x="5852159" y="4389120"/>
-            <a:ext cx="1280160" cy="777240"/>
-          </a:xfrm>
-          <a:prstGeom prst="rect">
-            <a:avLst/>
-          </a:prstGeom>
-          <a:noFill/>
-        </p:spPr>
-        <p:txBody>
-          <a:bodyPr wrap="square" anchor="ctr" lIns="0" tIns="0" rIns="0" bIns="0">
-            <a:spAutoFit/>
-          </a:bodyPr>
-          <a:lstStyle/>
-          <a:p>
-            <a:pPr algn="r">
-              <a:spcAft>
-                <a:spcPts val="0"/>
-              </a:spcAft>
-            </a:pPr>
-            <a:r>
-              <a:rPr sz="1600" b="0">
-                <a:solidFill>
-                  <a:srgbClr val="111111"/>
-                </a:solidFill>
-                <a:latin typeface="Arial"/>
-                <a:ea typeface="Arial"/>
-                <a:cs typeface="Arial"/>
-              </a:rPr>
-              <a:t>₹1.30</a:t>
-            </a:r>
-          </a:p>
-        </p:txBody>
-      </p:sp>
-      <p:cxnSp>
-        <p:nvCxnSpPr>
-          <p:cNvPr id="23" name="Connector"/>
-          <p:cNvCxnSpPr/>
-          <p:nvPr/>
-        </p:nvCxnSpPr>
-        <p:spPr>
-          <a:xfrm>
-            <a:off x="640080" y="5166359"/>
-            <a:ext cx="6583680" cy="0"/>
-          </a:xfrm>
-          <a:prstGeom prst="line">
-            <a:avLst/>
-          </a:prstGeom>
-          <a:ln w="9525">
-            <a:solidFill>
-              <a:srgbClr val="D9DADD"/>
-            </a:solidFill>
-          </a:ln>
-          <a:effectLst/>
-        </p:spPr>
-        <p:style>
-          <a:lnRef idx="2">
-            <a:schemeClr val="accent1"/>
-          </a:lnRef>
-          <a:fillRef idx="0">
-            <a:schemeClr val="accent1"/>
-          </a:fillRef>
-          <a:effectRef idx="1">
-            <a:schemeClr val="accent1"/>
-          </a:effectRef>
-          <a:fontRef idx="minor">
-            <a:schemeClr val="tx1"/>
-          </a:fontRef>
-        </p:style>
-      </p:cxnSp>
-      <p:sp>
-        <p:nvSpPr>
-          <p:cNvPr id="24" name="Stat tile"/>
+          <p:cNvPr id="8" name="Stat tile"/>
           <p:cNvSpPr/>
           <p:nvPr/>
         </p:nvSpPr>
         <p:spPr>
           <a:xfrm>
-            <a:off x="7635240" y="2057400"/>
-            <a:ext cx="3916375" cy="3108960"/>
+            <a:off x="640080" y="2057400"/>
+            <a:ext cx="3515258" cy="1691640"/>
           </a:xfrm>
           <a:prstGeom prst="roundRect">
             <a:avLst>
-              <a:gd name="adj" fmla="val 4117"/>
+              <a:gd name="adj" fmla="val 7567"/>
             </a:avLst>
           </a:prstGeom>
           <a:solidFill>
@@ -4298,7 +3746,7 @@
               </a:spcAft>
             </a:pPr>
             <a:r>
-              <a:rPr sz="5400" b="1">
+              <a:rPr sz="4400" b="1">
                 <a:solidFill>
                   <a:srgbClr val="111111"/>
                 </a:solidFill>
@@ -4331,14 +3779,172 @@
       </p:sp>
       <p:sp>
         <p:nvSpPr>
-          <p:cNvPr id="25" name="Text"/>
+          <p:cNvPr id="9" name="Stat tile"/>
+          <p:cNvSpPr/>
+          <p:nvPr/>
+        </p:nvSpPr>
+        <p:spPr>
+          <a:xfrm>
+            <a:off x="4338218" y="2057400"/>
+            <a:ext cx="3515258" cy="1691640"/>
+          </a:xfrm>
+          <a:prstGeom prst="roundRect">
+            <a:avLst>
+              <a:gd name="adj" fmla="val 7567"/>
+            </a:avLst>
+          </a:prstGeom>
+          <a:solidFill>
+            <a:srgbClr val="14171B"/>
+          </a:solidFill>
+          <a:ln>
+            <a:noFill/>
+          </a:ln>
+          <a:effectLst/>
+        </p:spPr>
+        <p:style>
+          <a:lnRef idx="1">
+            <a:schemeClr val="accent1"/>
+          </a:lnRef>
+          <a:fillRef idx="3">
+            <a:schemeClr val="accent1"/>
+          </a:fillRef>
+          <a:effectRef idx="2">
+            <a:schemeClr val="accent1"/>
+          </a:effectRef>
+          <a:fontRef idx="minor">
+            <a:schemeClr val="lt1"/>
+          </a:fontRef>
+        </p:style>
+        <p:txBody>
+          <a:bodyPr rtlCol="0" anchor="ctr" wrap="square" lIns="274320" tIns="91440" rIns="228600" bIns="91440"/>
+          <a:lstStyle/>
+          <a:p>
+            <a:pPr algn="l">
+              <a:spcAft>
+                <a:spcPts val="400"/>
+              </a:spcAft>
+            </a:pPr>
+            <a:r>
+              <a:rPr sz="4400" b="1">
+                <a:solidFill>
+                  <a:srgbClr val="F59E0B"/>
+                </a:solidFill>
+                <a:latin typeface="Arial"/>
+                <a:ea typeface="Arial"/>
+                <a:cs typeface="Arial"/>
+              </a:rPr>
+              <a:t>≈ ₹50</a:t>
+            </a:r>
+          </a:p>
+          <a:p>
+            <a:pPr algn="l">
+              <a:spcAft>
+                <a:spcPts val="400"/>
+              </a:spcAft>
+            </a:pPr>
+            <a:r>
+              <a:rPr sz="1600" b="0">
+                <a:solidFill>
+                  <a:srgbClr val="E5E7EB"/>
+                </a:solidFill>
+                <a:latin typeface="Arial"/>
+                <a:ea typeface="Arial"/>
+                <a:cs typeface="Arial"/>
+              </a:rPr>
+              <a:t>per 20-min run</a:t>
+            </a:r>
+          </a:p>
+        </p:txBody>
+      </p:sp>
+      <p:sp>
+        <p:nvSpPr>
+          <p:cNvPr id="10" name="Stat tile"/>
+          <p:cNvSpPr/>
+          <p:nvPr/>
+        </p:nvSpPr>
+        <p:spPr>
+          <a:xfrm>
+            <a:off x="8036356" y="2057400"/>
+            <a:ext cx="3515258" cy="1691640"/>
+          </a:xfrm>
+          <a:prstGeom prst="roundRect">
+            <a:avLst>
+              <a:gd name="adj" fmla="val 7567"/>
+            </a:avLst>
+          </a:prstGeom>
+          <a:solidFill>
+            <a:srgbClr val="14171B"/>
+          </a:solidFill>
+          <a:ln>
+            <a:noFill/>
+          </a:ln>
+          <a:effectLst/>
+        </p:spPr>
+        <p:style>
+          <a:lnRef idx="1">
+            <a:schemeClr val="accent1"/>
+          </a:lnRef>
+          <a:fillRef idx="3">
+            <a:schemeClr val="accent1"/>
+          </a:fillRef>
+          <a:effectRef idx="2">
+            <a:schemeClr val="accent1"/>
+          </a:effectRef>
+          <a:fontRef idx="minor">
+            <a:schemeClr val="lt1"/>
+          </a:fontRef>
+        </p:style>
+        <p:txBody>
+          <a:bodyPr rtlCol="0" anchor="ctr" wrap="square" lIns="274320" tIns="91440" rIns="228600" bIns="91440"/>
+          <a:lstStyle/>
+          <a:p>
+            <a:pPr algn="l">
+              <a:spcAft>
+                <a:spcPts val="400"/>
+              </a:spcAft>
+            </a:pPr>
+            <a:r>
+              <a:rPr sz="4400" b="1">
+                <a:solidFill>
+                  <a:srgbClr val="F59E0B"/>
+                </a:solidFill>
+                <a:latin typeface="Arial"/>
+                <a:ea typeface="Arial"/>
+                <a:cs typeface="Arial"/>
+              </a:rPr>
+              <a:t>≈ ₹5,000</a:t>
+            </a:r>
+          </a:p>
+          <a:p>
+            <a:pPr algn="l">
+              <a:spcAft>
+                <a:spcPts val="400"/>
+              </a:spcAft>
+            </a:pPr>
+            <a:r>
+              <a:rPr sz="1600" b="0">
+                <a:solidFill>
+                  <a:srgbClr val="E5E7EB"/>
+                </a:solidFill>
+                <a:latin typeface="Arial"/>
+                <a:ea typeface="Arial"/>
+                <a:cs typeface="Arial"/>
+              </a:rPr>
+              <a:t>city-month at 100 runs (illustrative)</a:t>
+            </a:r>
+          </a:p>
+        </p:txBody>
+      </p:sp>
+      <p:sp>
+        <p:nvSpPr>
+          <p:cNvPr id="11" name="Cost cell"/>
           <p:cNvSpPr txBox="1"/>
           <p:nvPr/>
         </p:nvSpPr>
         <p:spPr>
           <a:xfrm>
-            <a:off x="640080" y="5394960"/>
-            <a:ext cx="10911535" cy="274320"/>
+            <a:off x="731519" y="4023360"/>
+            <a:ext cx="2194560" cy="566928"/>
           </a:xfrm>
           <a:prstGeom prst="rect">
             <a:avLst/>
@@ -4346,7 +3952,7 @@
           <a:noFill/>
         </p:spPr>
         <p:txBody>
-          <a:bodyPr wrap="square" anchor="t" lIns="0" tIns="0" rIns="0" bIns="0">
+          <a:bodyPr wrap="square" anchor="ctr" lIns="0" tIns="0" rIns="0" bIns="0">
             <a:spAutoFit/>
           </a:bodyPr>
           <a:lstStyle/>
@@ -4357,15 +3963,512 @@
               </a:spcAft>
             </a:pPr>
             <a:r>
-              <a:rPr sz="1300" b="0">
-                <a:solidFill>
-                  <a:srgbClr val="6B7280"/>
-                </a:solidFill>
-                <a:latin typeface="Arial"/>
-                <a:ea typeface="Arial"/>
-                <a:cs typeface="Arial"/>
-              </a:rPr>
-              <a:t>List prices; Routes is ~98 %.</a:t>
+              <a:rPr sz="1600" b="1">
+                <a:solidFill>
+                  <a:srgbClr val="111111"/>
+                </a:solidFill>
+                <a:latin typeface="Arial"/>
+                <a:ea typeface="Arial"/>
+                <a:cs typeface="Arial"/>
+              </a:rPr>
+              <a:t>Routes</a:t>
+            </a:r>
+          </a:p>
+        </p:txBody>
+      </p:sp>
+      <p:sp>
+        <p:nvSpPr>
+          <p:cNvPr id="12" name="Cost cell"/>
+          <p:cNvSpPr txBox="1"/>
+          <p:nvPr/>
+        </p:nvSpPr>
+        <p:spPr>
+          <a:xfrm>
+            <a:off x="3108960" y="4023360"/>
+            <a:ext cx="3108960" cy="566928"/>
+          </a:xfrm>
+          <a:prstGeom prst="rect">
+            <a:avLst/>
+          </a:prstGeom>
+          <a:noFill/>
+        </p:spPr>
+        <p:txBody>
+          <a:bodyPr wrap="square" anchor="ctr" lIns="0" tIns="0" rIns="0" bIns="0">
+            <a:spAutoFit/>
+          </a:bodyPr>
+          <a:lstStyle/>
+          <a:p>
+            <a:pPr algn="l">
+              <a:spcAft>
+                <a:spcPts val="0"/>
+              </a:spcAft>
+            </a:pPr>
+            <a:r>
+              <a:rPr sz="1600" b="0">
+                <a:solidFill>
+                  <a:srgbClr val="111111"/>
+                </a:solidFill>
+                <a:latin typeface="Arial"/>
+                <a:ea typeface="Arial"/>
+                <a:cs typeface="Arial"/>
+              </a:rPr>
+              <a:t>3/min × 60 × ₹0.85</a:t>
+            </a:r>
+          </a:p>
+        </p:txBody>
+      </p:sp>
+      <p:sp>
+        <p:nvSpPr>
+          <p:cNvPr id="13" name="Cost cell"/>
+          <p:cNvSpPr txBox="1"/>
+          <p:nvPr/>
+        </p:nvSpPr>
+        <p:spPr>
+          <a:xfrm>
+            <a:off x="6400800" y="4023360"/>
+            <a:ext cx="1280160" cy="566928"/>
+          </a:xfrm>
+          <a:prstGeom prst="rect">
+            <a:avLst/>
+          </a:prstGeom>
+          <a:noFill/>
+        </p:spPr>
+        <p:txBody>
+          <a:bodyPr wrap="square" anchor="ctr" lIns="0" tIns="0" rIns="0" bIns="0">
+            <a:spAutoFit/>
+          </a:bodyPr>
+          <a:lstStyle/>
+          <a:p>
+            <a:pPr algn="r">
+              <a:spcAft>
+                <a:spcPts val="0"/>
+              </a:spcAft>
+            </a:pPr>
+            <a:r>
+              <a:rPr sz="1600" b="0">
+                <a:solidFill>
+                  <a:srgbClr val="111111"/>
+                </a:solidFill>
+                <a:latin typeface="Arial"/>
+                <a:ea typeface="Arial"/>
+                <a:cs typeface="Arial"/>
+              </a:rPr>
+              <a:t>₹153</a:t>
+            </a:r>
+          </a:p>
+        </p:txBody>
+      </p:sp>
+      <p:cxnSp>
+        <p:nvCxnSpPr>
+          <p:cNvPr id="14" name="Connector"/>
+          <p:cNvCxnSpPr/>
+          <p:nvPr/>
+        </p:nvCxnSpPr>
+        <p:spPr>
+          <a:xfrm>
+            <a:off x="640080" y="4590288"/>
+            <a:ext cx="7132320" cy="0"/>
+          </a:xfrm>
+          <a:prstGeom prst="line">
+            <a:avLst/>
+          </a:prstGeom>
+          <a:ln w="9525">
+            <a:solidFill>
+              <a:srgbClr val="D9DADD"/>
+            </a:solidFill>
+          </a:ln>
+          <a:effectLst/>
+        </p:spPr>
+        <p:style>
+          <a:lnRef idx="2">
+            <a:schemeClr val="accent1"/>
+          </a:lnRef>
+          <a:fillRef idx="0">
+            <a:schemeClr val="accent1"/>
+          </a:fillRef>
+          <a:effectRef idx="1">
+            <a:schemeClr val="accent1"/>
+          </a:effectRef>
+          <a:fontRef idx="minor">
+            <a:schemeClr val="tx1"/>
+          </a:fontRef>
+        </p:style>
+      </p:cxnSp>
+      <p:sp>
+        <p:nvSpPr>
+          <p:cNvPr id="15" name="Cost cell"/>
+          <p:cNvSpPr txBox="1"/>
+          <p:nvPr/>
+        </p:nvSpPr>
+        <p:spPr>
+          <a:xfrm>
+            <a:off x="731519" y="4590288"/>
+            <a:ext cx="2194560" cy="566928"/>
+          </a:xfrm>
+          <a:prstGeom prst="rect">
+            <a:avLst/>
+          </a:prstGeom>
+          <a:noFill/>
+        </p:spPr>
+        <p:txBody>
+          <a:bodyPr wrap="square" anchor="ctr" lIns="0" tIns="0" rIns="0" bIns="0">
+            <a:spAutoFit/>
+          </a:bodyPr>
+          <a:lstStyle/>
+          <a:p>
+            <a:pPr algn="l">
+              <a:spcAft>
+                <a:spcPts val="0"/>
+              </a:spcAft>
+            </a:pPr>
+            <a:r>
+              <a:rPr sz="1600" b="1">
+                <a:solidFill>
+                  <a:srgbClr val="111111"/>
+                </a:solidFill>
+                <a:latin typeface="Arial"/>
+                <a:ea typeface="Arial"/>
+                <a:cs typeface="Arial"/>
+              </a:rPr>
+              <a:t>Gemini</a:t>
+            </a:r>
+          </a:p>
+        </p:txBody>
+      </p:sp>
+      <p:sp>
+        <p:nvSpPr>
+          <p:cNvPr id="16" name="Cost cell"/>
+          <p:cNvSpPr txBox="1"/>
+          <p:nvPr/>
+        </p:nvSpPr>
+        <p:spPr>
+          <a:xfrm>
+            <a:off x="3108960" y="4590288"/>
+            <a:ext cx="3108960" cy="566928"/>
+          </a:xfrm>
+          <a:prstGeom prst="rect">
+            <a:avLst/>
+          </a:prstGeom>
+          <a:noFill/>
+        </p:spPr>
+        <p:txBody>
+          <a:bodyPr wrap="square" anchor="ctr" lIns="0" tIns="0" rIns="0" bIns="0">
+            <a:spAutoFit/>
+          </a:bodyPr>
+          <a:lstStyle/>
+          <a:p>
+            <a:pPr algn="l">
+              <a:spcAft>
+                <a:spcPts val="0"/>
+              </a:spcAft>
+            </a:pPr>
+            <a:r>
+              <a:rPr sz="1600" b="0">
+                <a:solidFill>
+                  <a:srgbClr val="111111"/>
+                </a:solidFill>
+                <a:latin typeface="Arial"/>
+                <a:ea typeface="Arial"/>
+                <a:cs typeface="Arial"/>
+              </a:rPr>
+              <a:t>17 × ₹0.02</a:t>
+            </a:r>
+          </a:p>
+        </p:txBody>
+      </p:sp>
+      <p:sp>
+        <p:nvSpPr>
+          <p:cNvPr id="17" name="Cost cell"/>
+          <p:cNvSpPr txBox="1"/>
+          <p:nvPr/>
+        </p:nvSpPr>
+        <p:spPr>
+          <a:xfrm>
+            <a:off x="6400800" y="4590288"/>
+            <a:ext cx="1280160" cy="566928"/>
+          </a:xfrm>
+          <a:prstGeom prst="rect">
+            <a:avLst/>
+          </a:prstGeom>
+          <a:noFill/>
+        </p:spPr>
+        <p:txBody>
+          <a:bodyPr wrap="square" anchor="ctr" lIns="0" tIns="0" rIns="0" bIns="0">
+            <a:spAutoFit/>
+          </a:bodyPr>
+          <a:lstStyle/>
+          <a:p>
+            <a:pPr algn="r">
+              <a:spcAft>
+                <a:spcPts val="0"/>
+              </a:spcAft>
+            </a:pPr>
+            <a:r>
+              <a:rPr sz="1600" b="0">
+                <a:solidFill>
+                  <a:srgbClr val="111111"/>
+                </a:solidFill>
+                <a:latin typeface="Arial"/>
+                <a:ea typeface="Arial"/>
+                <a:cs typeface="Arial"/>
+              </a:rPr>
+              <a:t>₹0.34</a:t>
+            </a:r>
+          </a:p>
+        </p:txBody>
+      </p:sp>
+      <p:cxnSp>
+        <p:nvCxnSpPr>
+          <p:cNvPr id="18" name="Connector"/>
+          <p:cNvCxnSpPr/>
+          <p:nvPr/>
+        </p:nvCxnSpPr>
+        <p:spPr>
+          <a:xfrm>
+            <a:off x="640080" y="5157216"/>
+            <a:ext cx="7132320" cy="0"/>
+          </a:xfrm>
+          <a:prstGeom prst="line">
+            <a:avLst/>
+          </a:prstGeom>
+          <a:ln w="9525">
+            <a:solidFill>
+              <a:srgbClr val="D9DADD"/>
+            </a:solidFill>
+          </a:ln>
+          <a:effectLst/>
+        </p:spPr>
+        <p:style>
+          <a:lnRef idx="2">
+            <a:schemeClr val="accent1"/>
+          </a:lnRef>
+          <a:fillRef idx="0">
+            <a:schemeClr val="accent1"/>
+          </a:fillRef>
+          <a:effectRef idx="1">
+            <a:schemeClr val="accent1"/>
+          </a:effectRef>
+          <a:fontRef idx="minor">
+            <a:schemeClr val="tx1"/>
+          </a:fontRef>
+        </p:style>
+      </p:cxnSp>
+      <p:sp>
+        <p:nvSpPr>
+          <p:cNvPr id="19" name="Cost cell"/>
+          <p:cNvSpPr txBox="1"/>
+          <p:nvPr/>
+        </p:nvSpPr>
+        <p:spPr>
+          <a:xfrm>
+            <a:off x="731519" y="5157216"/>
+            <a:ext cx="2194560" cy="566928"/>
+          </a:xfrm>
+          <a:prstGeom prst="rect">
+            <a:avLst/>
+          </a:prstGeom>
+          <a:noFill/>
+        </p:spPr>
+        <p:txBody>
+          <a:bodyPr wrap="square" anchor="ctr" lIns="0" tIns="0" rIns="0" bIns="0">
+            <a:spAutoFit/>
+          </a:bodyPr>
+          <a:lstStyle/>
+          <a:p>
+            <a:pPr algn="l">
+              <a:spcAft>
+                <a:spcPts val="0"/>
+              </a:spcAft>
+            </a:pPr>
+            <a:r>
+              <a:rPr sz="1600" b="1">
+                <a:solidFill>
+                  <a:srgbClr val="111111"/>
+                </a:solidFill>
+                <a:latin typeface="Arial"/>
+                <a:ea typeface="Arial"/>
+                <a:cs typeface="Arial"/>
+              </a:rPr>
+              <a:t>Text-to-Speech</a:t>
+            </a:r>
+          </a:p>
+        </p:txBody>
+      </p:sp>
+      <p:sp>
+        <p:nvSpPr>
+          <p:cNvPr id="20" name="Cost cell"/>
+          <p:cNvSpPr txBox="1"/>
+          <p:nvPr/>
+        </p:nvSpPr>
+        <p:spPr>
+          <a:xfrm>
+            <a:off x="3108960" y="5157216"/>
+            <a:ext cx="3108960" cy="566928"/>
+          </a:xfrm>
+          <a:prstGeom prst="rect">
+            <a:avLst/>
+          </a:prstGeom>
+          <a:noFill/>
+        </p:spPr>
+        <p:txBody>
+          <a:bodyPr wrap="square" anchor="ctr" lIns="0" tIns="0" rIns="0" bIns="0">
+            <a:spAutoFit/>
+          </a:bodyPr>
+          <a:lstStyle/>
+          <a:p>
+            <a:pPr algn="l">
+              <a:spcAft>
+                <a:spcPts val="0"/>
+              </a:spcAft>
+            </a:pPr>
+            <a:r>
+              <a:rPr sz="1600" b="0">
+                <a:solidFill>
+                  <a:srgbClr val="111111"/>
+                </a:solidFill>
+                <a:latin typeface="Arial"/>
+                <a:ea typeface="Arial"/>
+                <a:cs typeface="Arial"/>
+              </a:rPr>
+              <a:t/>
+            </a:r>
+          </a:p>
+        </p:txBody>
+      </p:sp>
+      <p:sp>
+        <p:nvSpPr>
+          <p:cNvPr id="21" name="Cost cell"/>
+          <p:cNvSpPr txBox="1"/>
+          <p:nvPr/>
+        </p:nvSpPr>
+        <p:spPr>
+          <a:xfrm>
+            <a:off x="6400800" y="5157216"/>
+            <a:ext cx="1280160" cy="566928"/>
+          </a:xfrm>
+          <a:prstGeom prst="rect">
+            <a:avLst/>
+          </a:prstGeom>
+          <a:noFill/>
+        </p:spPr>
+        <p:txBody>
+          <a:bodyPr wrap="square" anchor="ctr" lIns="0" tIns="0" rIns="0" bIns="0">
+            <a:spAutoFit/>
+          </a:bodyPr>
+          <a:lstStyle/>
+          <a:p>
+            <a:pPr algn="r">
+              <a:spcAft>
+                <a:spcPts val="0"/>
+              </a:spcAft>
+            </a:pPr>
+            <a:r>
+              <a:rPr sz="1600" b="0">
+                <a:solidFill>
+                  <a:srgbClr val="111111"/>
+                </a:solidFill>
+                <a:latin typeface="Arial"/>
+                <a:ea typeface="Arial"/>
+                <a:cs typeface="Arial"/>
+              </a:rPr>
+              <a:t>₹1.30</a:t>
+            </a:r>
+          </a:p>
+        </p:txBody>
+      </p:sp>
+      <p:cxnSp>
+        <p:nvCxnSpPr>
+          <p:cNvPr id="22" name="Connector"/>
+          <p:cNvCxnSpPr/>
+          <p:nvPr/>
+        </p:nvCxnSpPr>
+        <p:spPr>
+          <a:xfrm>
+            <a:off x="640080" y="5724144"/>
+            <a:ext cx="7132320" cy="0"/>
+          </a:xfrm>
+          <a:prstGeom prst="line">
+            <a:avLst/>
+          </a:prstGeom>
+          <a:ln w="9525">
+            <a:solidFill>
+              <a:srgbClr val="D9DADD"/>
+            </a:solidFill>
+          </a:ln>
+          <a:effectLst/>
+        </p:spPr>
+        <p:style>
+          <a:lnRef idx="2">
+            <a:schemeClr val="accent1"/>
+          </a:lnRef>
+          <a:fillRef idx="0">
+            <a:schemeClr val="accent1"/>
+          </a:fillRef>
+          <a:effectRef idx="1">
+            <a:schemeClr val="accent1"/>
+          </a:effectRef>
+          <a:fontRef idx="minor">
+            <a:schemeClr val="tx1"/>
+          </a:fontRef>
+        </p:style>
+      </p:cxnSp>
+      <p:sp>
+        <p:nvSpPr>
+          <p:cNvPr id="23" name="Lever"/>
+          <p:cNvSpPr/>
+          <p:nvPr/>
+        </p:nvSpPr>
+        <p:spPr>
+          <a:xfrm>
+            <a:off x="8138160" y="4023360"/>
+            <a:ext cx="3413455" cy="1700784"/>
+          </a:xfrm>
+          <a:prstGeom prst="roundRect">
+            <a:avLst>
+              <a:gd name="adj" fmla="val 6451"/>
+            </a:avLst>
+          </a:prstGeom>
+          <a:solidFill>
+            <a:srgbClr val="FEF3C7"/>
+          </a:solidFill>
+          <a:ln>
+            <a:noFill/>
+          </a:ln>
+          <a:effectLst/>
+        </p:spPr>
+        <p:style>
+          <a:lnRef idx="1">
+            <a:schemeClr val="accent1"/>
+          </a:lnRef>
+          <a:fillRef idx="3">
+            <a:schemeClr val="accent1"/>
+          </a:fillRef>
+          <a:effectRef idx="2">
+            <a:schemeClr val="accent1"/>
+          </a:effectRef>
+          <a:fontRef idx="minor">
+            <a:schemeClr val="lt1"/>
+          </a:fontRef>
+        </p:style>
+        <p:txBody>
+          <a:bodyPr rtlCol="0" anchor="ctr" wrap="square" lIns="228600" tIns="91440" rIns="182880" bIns="91440"/>
+          <a:lstStyle/>
+          <a:p>
+            <a:pPr algn="l">
+              <a:spcAft>
+                <a:spcPts val="400"/>
+              </a:spcAft>
+            </a:pPr>
+            <a:r>
+              <a:rPr sz="1600" b="1">
+                <a:solidFill>
+                  <a:srgbClr val="111111"/>
+                </a:solidFill>
+                <a:latin typeface="Arial"/>
+                <a:ea typeface="Arial"/>
+                <a:cs typeface="Arial"/>
+              </a:rPr>
+              <a:t>Lever: cache Routes beyond today's 20 s</a:t>
             </a:r>
           </a:p>
         </p:txBody>
@@ -4654,7 +4757,7 @@
         <p:spPr>
           <a:xfrm>
             <a:off x="640080" y="2011679"/>
-            <a:ext cx="5272887" cy="1691640"/>
+            <a:ext cx="6035040" cy="3383280"/>
           </a:xfrm>
           <a:prstGeom prst="rect">
             <a:avLst/>
@@ -4681,8 +4784,8 @@
         </p:nvSpPr>
         <p:spPr>
           <a:xfrm>
-            <a:off x="640080" y="3794759"/>
-            <a:ext cx="5272887" cy="274320"/>
+            <a:off x="640080" y="5486400"/>
+            <a:ext cx="6035040" cy="274320"/>
           </a:xfrm>
           <a:prstGeom prst="rect">
             <a:avLst/>
@@ -4709,7 +4812,7 @@
                 <a:ea typeface="Arial"/>
                 <a:cs typeface="Arial"/>
               </a:rPr>
-              <a:t>Control room</a:t>
+              <a:t>Replay simulator</a:t>
             </a:r>
           </a:p>
         </p:txBody>
@@ -4730,8 +4833,8 @@
         </p:blipFill>
         <p:spPr>
           <a:xfrm>
-            <a:off x="6278727" y="2011679"/>
-            <a:ext cx="5272887" cy="1691640"/>
+            <a:off x="7040880" y="2011679"/>
+            <a:ext cx="4510735" cy="1463040"/>
           </a:xfrm>
           <a:prstGeom prst="rect">
             <a:avLst/>
@@ -4758,8 +4861,8 @@
         </p:nvSpPr>
         <p:spPr>
           <a:xfrm>
-            <a:off x="6278727" y="3794759"/>
-            <a:ext cx="5272887" cy="274320"/>
+            <a:off x="7040880" y="3566160"/>
+            <a:ext cx="4510735" cy="274320"/>
           </a:xfrm>
           <a:prstGeom prst="rect">
             <a:avLst/>
@@ -4786,7 +4889,7 @@
                 <a:ea typeface="Arial"/>
                 <a:cs typeface="Arial"/>
               </a:rPr>
-              <a:t>Replay simulator</a:t>
+              <a:t>Control room</a:t>
             </a:r>
           </a:p>
         </p:txBody>
@@ -4807,8 +4910,8 @@
         </p:blipFill>
         <p:spPr>
           <a:xfrm>
-            <a:off x="640080" y="4160520"/>
-            <a:ext cx="5272887" cy="1691640"/>
+            <a:off x="7040880" y="3977639"/>
+            <a:ext cx="4510735" cy="1417320"/>
           </a:xfrm>
           <a:prstGeom prst="rect">
             <a:avLst/>
@@ -4835,8 +4938,8 @@
         </p:nvSpPr>
         <p:spPr>
           <a:xfrm>
-            <a:off x="640080" y="5943600"/>
-            <a:ext cx="5272887" cy="274320"/>
+            <a:off x="7040880" y="5486400"/>
+            <a:ext cx="4510735" cy="274320"/>
           </a:xfrm>
           <a:prstGeom prst="rect">
             <a:avLst/>
@@ -4863,84 +4966,7 @@
                 <a:ea typeface="Arial"/>
                 <a:cs typeface="Arial"/>
               </a:rPr>
-              <a:t>Routing trace</a:t>
-            </a:r>
-          </a:p>
-        </p:txBody>
-      </p:sp>
-      <p:pic>
-        <p:nvPicPr>
-          <p:cNvPr id="14" name="Screenshot" descr="image.jpg"/>
-          <p:cNvPicPr>
-            <a:picLocks noChangeAspect="1"/>
-          </p:cNvPicPr>
-          <p:nvPr/>
-        </p:nvPicPr>
-        <p:blipFill>
-          <a:blip r:embed="rId5"/>
-          <a:stretch>
-            <a:fillRect/>
-          </a:stretch>
-        </p:blipFill>
-        <p:spPr>
-          <a:xfrm>
-            <a:off x="6278727" y="4160520"/>
-            <a:ext cx="5272887" cy="1691640"/>
-          </a:xfrm>
-          <a:prstGeom prst="rect">
-            <a:avLst/>
-          </a:prstGeom>
-          <a:ln w="9525">
-            <a:solidFill>
-              <a:srgbClr val="2B2D31"/>
-            </a:solidFill>
-          </a:ln>
-          <a:effectLst>
-            <a:outerShdw blurRad="152400" dist="38100" dir="5400000" algn="t" rotWithShape="0">
-              <a:srgbClr val="000000">
-                <a:alpha val="26000"/>
-              </a:srgbClr>
-            </a:outerShdw>
-          </a:effectLst>
-        </p:spPr>
-      </p:pic>
-      <p:sp>
-        <p:nvSpPr>
-          <p:cNvPr id="15" name="Text"/>
-          <p:cNvSpPr txBox="1"/>
-          <p:nvPr/>
-        </p:nvSpPr>
-        <p:spPr>
-          <a:xfrm>
-            <a:off x="6278727" y="5943600"/>
-            <a:ext cx="5272887" cy="274320"/>
-          </a:xfrm>
-          <a:prstGeom prst="rect">
-            <a:avLst/>
-          </a:prstGeom>
-          <a:noFill/>
-        </p:spPr>
-        <p:txBody>
-          <a:bodyPr wrap="square" anchor="t" lIns="0" tIns="0" rIns="0" bIns="0">
-            <a:spAutoFit/>
-          </a:bodyPr>
-          <a:lstStyle/>
-          <a:p>
-            <a:pPr algn="l">
-              <a:spcAft>
-                <a:spcPts val="0"/>
-              </a:spcAft>
-            </a:pPr>
-            <a:r>
-              <a:rPr sz="1300" b="1">
-                <a:solidFill>
-                  <a:srgbClr val="374151"/>
-                </a:solidFill>
-                <a:latin typeface="Arial"/>
-                <a:ea typeface="Arial"/>
-                <a:cs typeface="Arial"/>
-              </a:rPr>
-              <a:t>Hospital log</a:t>
+              <a:t>STOP alert, spoken</a:t>
             </a:r>
           </a:p>
         </p:txBody>
@@ -5811,7 +5837,7 @@
         <p:spPr>
           <a:xfrm>
             <a:off x="640080" y="2011679"/>
-            <a:ext cx="2590723" cy="1737360"/>
+            <a:ext cx="3515258" cy="1737360"/>
           </a:xfrm>
           <a:prstGeom prst="roundRect">
             <a:avLst>
@@ -5850,7 +5876,7 @@
               </a:spcAft>
             </a:pPr>
             <a:r>
-              <a:rPr sz="4800" b="1">
+              <a:rPr sz="5400" b="1">
                 <a:solidFill>
                   <a:srgbClr val="F59E0B"/>
                 </a:solidFill>
@@ -5900,8 +5926,8 @@
         </p:nvSpPr>
         <p:spPr>
           <a:xfrm>
-            <a:off x="3413683" y="2011679"/>
-            <a:ext cx="2590723" cy="1737360"/>
+            <a:off x="4338218" y="2011679"/>
+            <a:ext cx="3515258" cy="1737360"/>
           </a:xfrm>
           <a:prstGeom prst="roundRect">
             <a:avLst>
@@ -5940,7 +5966,7 @@
               </a:spcAft>
             </a:pPr>
             <a:r>
-              <a:rPr sz="4800" b="1">
+              <a:rPr sz="5400" b="1">
                 <a:solidFill>
                   <a:srgbClr val="F59E0B"/>
                 </a:solidFill>
@@ -5990,8 +6016,8 @@
         </p:nvSpPr>
         <p:spPr>
           <a:xfrm>
-            <a:off x="6187287" y="2011679"/>
-            <a:ext cx="2590723" cy="1737360"/>
+            <a:off x="8036356" y="2011679"/>
+            <a:ext cx="3515258" cy="1737360"/>
           </a:xfrm>
           <a:prstGeom prst="roundRect">
             <a:avLst>
@@ -6030,7 +6056,7 @@
               </a:spcAft>
             </a:pPr>
             <a:r>
-              <a:rPr sz="4800" b="1">
+              <a:rPr sz="5400" b="1">
                 <a:solidFill>
                   <a:srgbClr val="F59E0B"/>
                 </a:solidFill>
@@ -6074,18 +6100,59 @@
       </p:sp>
       <p:sp>
         <p:nvSpPr>
-          <p:cNvPr id="11" name="Stat tile"/>
+          <p:cNvPr id="11" name="Text"/>
+          <p:cNvSpPr txBox="1"/>
+          <p:nvPr/>
+        </p:nvSpPr>
+        <p:spPr>
+          <a:xfrm>
+            <a:off x="640080" y="3886200"/>
+            <a:ext cx="10911535" cy="457200"/>
+          </a:xfrm>
+          <a:prstGeom prst="rect">
+            <a:avLst/>
+          </a:prstGeom>
+          <a:noFill/>
+        </p:spPr>
+        <p:txBody>
+          <a:bodyPr wrap="square" anchor="t" lIns="0" tIns="0" rIns="0" bIns="0">
+            <a:spAutoFit/>
+          </a:bodyPr>
+          <a:lstStyle/>
+          <a:p>
+            <a:pPr algn="l">
+              <a:spcAft>
+                <a:spcPts val="0"/>
+              </a:spcAft>
+            </a:pPr>
+            <a:r>
+              <a:rPr sz="1200" b="0">
+                <a:solidFill>
+                  <a:srgbClr val="6B7280"/>
+                </a:solidFill>
+                <a:latin typeface="Arial"/>
+                <a:ea typeface="Arial"/>
+                <a:cs typeface="Arial"/>
+              </a:rPr>
+              <a:t>11 synthetic clips, the ones the fix targeted; real clips pending. Before the fix: 87 % / 73 %.</a:t>
+            </a:r>
+          </a:p>
+        </p:txBody>
+      </p:sp>
+      <p:sp>
+        <p:nvSpPr>
+          <p:cNvPr id="12" name="Stat tile"/>
           <p:cNvSpPr/>
           <p:nvPr/>
         </p:nvSpPr>
         <p:spPr>
           <a:xfrm>
-            <a:off x="8960891" y="2011679"/>
-            <a:ext cx="2590723" cy="1737360"/>
+            <a:off x="640080" y="4389120"/>
+            <a:ext cx="5120640" cy="1645920"/>
           </a:xfrm>
           <a:prstGeom prst="roundRect">
             <a:avLst>
-              <a:gd name="adj" fmla="val 7368"/>
+              <a:gd name="adj" fmla="val 7777"/>
             </a:avLst>
           </a:prstGeom>
           <a:solidFill>
@@ -6128,7 +6195,18 @@
                 <a:ea typeface="Arial"/>
                 <a:cs typeface="Arial"/>
               </a:rPr>
-              <a:t>4 vs 1</a:t>
+              <a:t>17 / 37</a:t>
+            </a:r>
+            <a:r>
+              <a:rPr sz="2200" b="1">
+                <a:solidFill>
+                  <a:srgbClr val="F59E0B"/>
+                </a:solidFill>
+                <a:latin typeface="Arial"/>
+                <a:ea typeface="Arial"/>
+                <a:cs typeface="Arial"/>
+              </a:rPr>
+              <a:t> ms</a:t>
             </a:r>
           </a:p>
           <a:p>
@@ -6146,48 +6224,7 @@
                 <a:ea typeface="Arial"/>
                 <a:cs typeface="Arial"/>
               </a:rPr>
-              <a:t>min lead, long vs short</a:t>
-            </a:r>
-          </a:p>
-        </p:txBody>
-      </p:sp>
-      <p:sp>
-        <p:nvSpPr>
-          <p:cNvPr id="12" name="Text"/>
-          <p:cNvSpPr txBox="1"/>
-          <p:nvPr/>
-        </p:nvSpPr>
-        <p:spPr>
-          <a:xfrm>
-            <a:off x="640080" y="3886200"/>
-            <a:ext cx="10911535" cy="274320"/>
-          </a:xfrm>
-          <a:prstGeom prst="rect">
-            <a:avLst/>
-          </a:prstGeom>
-          <a:noFill/>
-        </p:spPr>
-        <p:txBody>
-          <a:bodyPr wrap="square" anchor="t" lIns="0" tIns="0" rIns="0" bIns="0">
-            <a:spAutoFit/>
-          </a:bodyPr>
-          <a:lstStyle/>
-          <a:p>
-            <a:pPr algn="l">
-              <a:spcAft>
-                <a:spcPts val="0"/>
-              </a:spcAft>
-            </a:pPr>
-            <a:r>
-              <a:rPr sz="1200" b="0">
-                <a:solidFill>
-                  <a:srgbClr val="6B7280"/>
-                </a:solidFill>
-                <a:latin typeface="Arial"/>
-                <a:ea typeface="Arial"/>
-                <a:cs typeface="Arial"/>
-              </a:rPr>
-              <a:t>11 synthetic clips, not field data. Before the fix: 87 % / 73 %.</a:t>
+              <a:t>/location p50 / p95, offline</a:t>
             </a:r>
           </a:p>
         </p:txBody>
@@ -6200,8 +6237,8 @@
         </p:nvSpPr>
         <p:spPr>
           <a:xfrm>
-            <a:off x="640080" y="4389120"/>
-            <a:ext cx="5120640" cy="1645920"/>
+            <a:off x="6035040" y="4389120"/>
+            <a:ext cx="5516575" cy="1645920"/>
           </a:xfrm>
           <a:prstGeom prst="roundRect">
             <a:avLst>
@@ -6231,16 +6268,16 @@
           </a:fontRef>
         </p:style>
         <p:txBody>
-          <a:bodyPr rtlCol="0" anchor="ctr" wrap="square" lIns="274320" tIns="91440" rIns="228600" bIns="91440"/>
-          <a:lstStyle/>
-          <a:p>
-            <a:pPr algn="l">
-              <a:spcAft>
-                <a:spcPts val="400"/>
-              </a:spcAft>
-            </a:pPr>
-            <a:r>
-              <a:rPr sz="4800" b="1">
+          <a:bodyPr rtlCol="0" anchor="ctr" wrap="square" lIns="274320" tIns="91440" rIns="182880" bIns="91440"/>
+          <a:lstStyle/>
+          <a:p>
+            <a:pPr algn="l">
+              <a:spcAft>
+                <a:spcPts val="600"/>
+              </a:spcAft>
+            </a:pPr>
+            <a:r>
+              <a:rPr sz="3200" b="1">
                 <a:solidFill>
                   <a:srgbClr val="F59E0B"/>
                 </a:solidFill>
@@ -6248,10 +6285,21 @@
                 <a:ea typeface="Arial"/>
                 <a:cs typeface="Arial"/>
               </a:rPr>
-              <a:t>17 / 37</a:t>
-            </a:r>
-            <a:r>
-              <a:rPr sz="2200" b="1">
+              <a:t>344</a:t>
+            </a:r>
+            <a:r>
+              <a:rPr sz="1800" b="0">
+                <a:solidFill>
+                  <a:srgbClr val="E5E7EB"/>
+                </a:solidFill>
+                <a:latin typeface="Arial"/>
+                <a:ea typeface="Arial"/>
+                <a:cs typeface="Arial"/>
+              </a:rPr>
+              <a:t> Python · </a:t>
+            </a:r>
+            <a:r>
+              <a:rPr sz="3200" b="1">
                 <a:solidFill>
                   <a:srgbClr val="F59E0B"/>
                 </a:solidFill>
@@ -6259,17 +6307,10 @@
                 <a:ea typeface="Arial"/>
                 <a:cs typeface="Arial"/>
               </a:rPr>
-              <a:t> ms</a:t>
-            </a:r>
-          </a:p>
-          <a:p>
-            <a:pPr algn="l">
-              <a:spcAft>
-                <a:spcPts val="400"/>
-              </a:spcAft>
-            </a:pPr>
-            <a:r>
-              <a:rPr sz="1600" b="0">
+              <a:t>138</a:t>
+            </a:r>
+            <a:r>
+              <a:rPr sz="1800" b="0">
                 <a:solidFill>
                   <a:srgbClr val="E5E7EB"/>
                 </a:solidFill>
@@ -6277,78 +6318,9 @@
                 <a:ea typeface="Arial"/>
                 <a:cs typeface="Arial"/>
               </a:rPr>
-              <a:t>/location p50 / p95, offline</a:t>
-            </a:r>
-          </a:p>
-        </p:txBody>
-      </p:sp>
-      <p:sp>
-        <p:nvSpPr>
-          <p:cNvPr id="14" name="Card"/>
-          <p:cNvSpPr/>
-          <p:nvPr/>
-        </p:nvSpPr>
-        <p:spPr>
-          <a:xfrm>
-            <a:off x="6035040" y="4389120"/>
-            <a:ext cx="5516575" cy="1645920"/>
-          </a:xfrm>
-          <a:prstGeom prst="roundRect">
-            <a:avLst>
-              <a:gd name="adj" fmla="val 7777"/>
-            </a:avLst>
-          </a:prstGeom>
-          <a:solidFill>
-            <a:srgbClr val="F5F6F7"/>
-          </a:solidFill>
-          <a:ln>
-            <a:noFill/>
-          </a:ln>
-          <a:effectLst/>
-        </p:spPr>
-        <p:style>
-          <a:lnRef idx="1">
-            <a:schemeClr val="accent1"/>
-          </a:lnRef>
-          <a:fillRef idx="3">
-            <a:schemeClr val="accent1"/>
-          </a:fillRef>
-          <a:effectRef idx="2">
-            <a:schemeClr val="accent1"/>
-          </a:effectRef>
-          <a:fontRef idx="minor">
-            <a:schemeClr val="lt1"/>
-          </a:fontRef>
-        </p:style>
-        <p:txBody>
-          <a:bodyPr rtlCol="0" anchor="ctr"/>
-          <a:lstStyle/>
-          <a:p>
-            <a:pPr algn="ctr"/>
-          </a:p>
-        </p:txBody>
-      </p:sp>
-      <p:sp>
-        <p:nvSpPr>
-          <p:cNvPr id="15" name="Text"/>
-          <p:cNvSpPr txBox="1"/>
-          <p:nvPr/>
-        </p:nvSpPr>
-        <p:spPr>
-          <a:xfrm>
-            <a:off x="6355080" y="4389120"/>
-            <a:ext cx="4876495" cy="1645920"/>
-          </a:xfrm>
-          <a:prstGeom prst="rect">
-            <a:avLst/>
-          </a:prstGeom>
-          <a:noFill/>
-        </p:spPr>
-        <p:txBody>
-          <a:bodyPr wrap="square" anchor="ctr" lIns="0" tIns="0" rIns="0" bIns="0">
-            <a:spAutoFit/>
-          </a:bodyPr>
-          <a:lstStyle/>
+              <a:t> web tests</a:t>
+            </a:r>
+          </a:p>
           <a:p>
             <a:pPr algn="l">
               <a:spcAft>
@@ -6356,71 +6328,20 @@
               </a:spcAft>
             </a:pPr>
             <a:r>
-              <a:rPr sz="2400" b="1">
-                <a:solidFill>
-                  <a:srgbClr val="111111"/>
-                </a:solidFill>
-                <a:latin typeface="Arial"/>
-                <a:ea typeface="Arial"/>
-                <a:cs typeface="Arial"/>
-              </a:rPr>
-              <a:t>344</a:t>
+              <a:rPr sz="3200" b="1">
+                <a:solidFill>
+                  <a:srgbClr val="F59E0B"/>
+                </a:solidFill>
+                <a:latin typeface="Arial"/>
+                <a:ea typeface="Arial"/>
+                <a:cs typeface="Arial"/>
+              </a:rPr>
+              <a:t>98 %</a:t>
             </a:r>
             <a:r>
               <a:rPr sz="1800" b="0">
                 <a:solidFill>
-                  <a:srgbClr val="111111"/>
-                </a:solidFill>
-                <a:latin typeface="Arial"/>
-                <a:ea typeface="Arial"/>
-                <a:cs typeface="Arial"/>
-              </a:rPr>
-              <a:t> Python · </a:t>
-            </a:r>
-            <a:r>
-              <a:rPr sz="2400" b="1">
-                <a:solidFill>
-                  <a:srgbClr val="111111"/>
-                </a:solidFill>
-                <a:latin typeface="Arial"/>
-                <a:ea typeface="Arial"/>
-                <a:cs typeface="Arial"/>
-              </a:rPr>
-              <a:t>138</a:t>
-            </a:r>
-            <a:r>
-              <a:rPr sz="1800" b="0">
-                <a:solidFill>
-                  <a:srgbClr val="111111"/>
-                </a:solidFill>
-                <a:latin typeface="Arial"/>
-                <a:ea typeface="Arial"/>
-                <a:cs typeface="Arial"/>
-              </a:rPr>
-              <a:t> web tests</a:t>
-            </a:r>
-          </a:p>
-          <a:p>
-            <a:pPr algn="l">
-              <a:spcAft>
-                <a:spcPts val="600"/>
-              </a:spcAft>
-            </a:pPr>
-            <a:r>
-              <a:rPr sz="2400" b="1">
-                <a:solidFill>
-                  <a:srgbClr val="111111"/>
-                </a:solidFill>
-                <a:latin typeface="Arial"/>
-                <a:ea typeface="Arial"/>
-                <a:cs typeface="Arial"/>
-              </a:rPr>
-              <a:t>98 %</a:t>
-            </a:r>
-            <a:r>
-              <a:rPr sz="1800" b="0">
-                <a:solidFill>
-                  <a:srgbClr val="111111"/>
+                  <a:srgbClr val="E5E7EB"/>
                 </a:solidFill>
                 <a:latin typeface="Arial"/>
                 <a:ea typeface="Arial"/>
@@ -7662,8 +7583,8 @@
         </p:nvSpPr>
         <p:spPr>
           <a:xfrm>
-            <a:off x="4643018" y="3337560"/>
-            <a:ext cx="2905658" cy="914400"/>
+            <a:off x="4643018" y="3246120"/>
+            <a:ext cx="2905658" cy="1280160"/>
           </a:xfrm>
           <a:prstGeom prst="rect">
             <a:avLst/>
@@ -7682,7 +7603,7 @@
               </a:spcAft>
             </a:pPr>
             <a:r>
-              <a:rPr sz="4400" b="1">
+              <a:rPr sz="2800" b="1">
                 <a:solidFill>
                   <a:srgbClr val="6B7280"/>
                 </a:solidFill>
@@ -7690,7 +7611,7 @@
                 <a:ea typeface="Arial"/>
                 <a:cs typeface="Arial"/>
               </a:rPr>
-              <a:t>[link]</a:t>
+              <a:t>[link + QR at submission]</a:t>
             </a:r>
           </a:p>
         </p:txBody>
@@ -9258,7 +9179,7 @@
             </a:avLst>
           </a:prstGeom>
           <a:solidFill>
-            <a:srgbClr val="14171B"/>
+            <a:srgbClr val="F59E0B"/>
           </a:solidFill>
           <a:ln>
             <a:noFill/>
@@ -9289,20 +9210,20 @@
               </a:spcAft>
             </a:pPr>
             <a:r>
-              <a:rPr sz="6400" b="1">
-                <a:solidFill>
-                  <a:srgbClr val="F59E0B"/>
-                </a:solidFill>
-                <a:latin typeface="Arial"/>
-                <a:ea typeface="Arial"/>
-                <a:cs typeface="Arial"/>
-              </a:rPr>
-              <a:t>16.5</a:t>
+              <a:rPr sz="6000" b="1">
+                <a:solidFill>
+                  <a:srgbClr val="111111"/>
+                </a:solidFill>
+                <a:latin typeface="Arial"/>
+                <a:ea typeface="Arial"/>
+                <a:cs typeface="Arial"/>
+              </a:rPr>
+              <a:t>≈ 7.9</a:t>
             </a:r>
             <a:r>
               <a:rPr sz="2200" b="1">
                 <a:solidFill>
-                  <a:srgbClr val="F59E0B"/>
+                  <a:srgbClr val="111111"/>
                 </a:solidFill>
                 <a:latin typeface="Arial"/>
                 <a:ea typeface="Arial"/>
@@ -9320,13 +9241,13 @@
             <a:r>
               <a:rPr sz="1600" b="0">
                 <a:solidFill>
-                  <a:srgbClr val="E5E7EB"/>
-                </a:solidFill>
-                <a:latin typeface="Arial"/>
-                <a:ea typeface="Arial"/>
-                <a:cs typeface="Arial"/>
-              </a:rPr>
-              <a:t>saved on the scripted scenario</a:t>
+                  <a:srgbClr val="111111"/>
+                </a:solidFill>
+                <a:latin typeface="Arial"/>
+                <a:ea typeface="Arial"/>
+                <a:cs typeface="Arial"/>
+              </a:rPr>
+              <a:t>saved for the critical ambulance</a:t>
             </a:r>
           </a:p>
         </p:txBody>
@@ -9379,7 +9300,7 @@
               </a:spcAft>
             </a:pPr>
             <a:r>
-              <a:rPr sz="6400" b="1">
+              <a:rPr sz="6000" b="1">
                 <a:solidFill>
                   <a:srgbClr val="F59E0B"/>
                 </a:solidFill>
@@ -9387,7 +9308,7 @@
                 <a:ea typeface="Arial"/>
                 <a:cs typeface="Arial"/>
               </a:rPr>
-              <a:t>4</a:t>
+              <a:t>4 vs 1</a:t>
             </a:r>
             <a:r>
               <a:rPr sz="2200" b="1">
@@ -9416,7 +9337,7 @@
                 <a:ea typeface="Arial"/>
                 <a:cs typeface="Arial"/>
               </a:rPr>
-              <a:t>warning at a 400 m queue</a:t>
+              <a:t>warning at a 400 m queue vs a 100 m queue</a:t>
             </a:r>
           </a:p>
         </p:txBody>
@@ -9469,7 +9390,7 @@
               </a:spcAft>
             </a:pPr>
             <a:r>
-              <a:rPr sz="6400" b="1">
+              <a:rPr sz="6000" b="1">
                 <a:solidFill>
                   <a:srgbClr val="F59E0B"/>
                 </a:solidFill>
@@ -9477,7 +9398,7 @@
                 <a:ea typeface="Arial"/>
                 <a:cs typeface="Arial"/>
               </a:rPr>
-              <a:t>100</a:t>
+              <a:t>16.5</a:t>
             </a:r>
             <a:r>
               <a:rPr sz="2200" b="1">
@@ -9488,7 +9409,7 @@
                 <a:ea typeface="Arial"/>
                 <a:cs typeface="Arial"/>
               </a:rPr>
-              <a:t> %</a:t>
+              <a:t> min</a:t>
             </a:r>
           </a:p>
           <a:p>
@@ -9506,7 +9427,7 @@
                 <a:ea typeface="Arial"/>
                 <a:cs typeface="Arial"/>
               </a:rPr>
-              <a:t>tier accuracy on 11 synthetic clips</a:t>
+              <a:t>three-vehicle total, simulated baseline</a:t>
             </a:r>
           </a:p>
         </p:txBody>
@@ -9892,7 +9813,7 @@
         </p:nvSpPr>
         <p:spPr>
           <a:xfrm>
-            <a:off x="960119" y="2377440"/>
+            <a:off x="960119" y="2331720"/>
             <a:ext cx="640080" cy="640080"/>
           </a:xfrm>
           <a:prstGeom prst="ellipse">
@@ -9951,7 +9872,7 @@
         </p:nvSpPr>
         <p:spPr>
           <a:xfrm>
-            <a:off x="960119" y="3246120"/>
+            <a:off x="960119" y="3154680"/>
             <a:ext cx="2875178" cy="320040"/>
           </a:xfrm>
           <a:prstGeom prst="rect">
@@ -9992,8 +9913,8 @@
         </p:nvSpPr>
         <p:spPr>
           <a:xfrm>
-            <a:off x="960119" y="3749039"/>
-            <a:ext cx="2875178" cy="1645920"/>
+            <a:off x="960119" y="3611880"/>
+            <a:ext cx="2875178" cy="1280160"/>
           </a:xfrm>
           <a:prstGeom prst="rect">
             <a:avLst/>
@@ -10020,14 +9941,75 @@
                 <a:ea typeface="Arial"/>
                 <a:cs typeface="Arial"/>
               </a:rPr>
-              <a:t>Warning sized to the queue, not a fixed radius</a:t>
-            </a:r>
-          </a:p>
-        </p:txBody>
-      </p:sp>
-      <p:sp>
-        <p:nvSpPr>
-          <p:cNvPr id="12" name="Card"/>
+              <a:t>Warning sized to the queue</a:t>
+            </a:r>
+          </a:p>
+        </p:txBody>
+      </p:sp>
+      <p:sp>
+        <p:nvSpPr>
+          <p:cNvPr id="12" name="Versus chip"/>
+          <p:cNvSpPr/>
+          <p:nvPr/>
+        </p:nvSpPr>
+        <p:spPr>
+          <a:xfrm>
+            <a:off x="960119" y="4937760"/>
+            <a:ext cx="2875178" cy="411480"/>
+          </a:xfrm>
+          <a:prstGeom prst="roundRect">
+            <a:avLst>
+              <a:gd name="adj" fmla="val 48888"/>
+            </a:avLst>
+          </a:prstGeom>
+          <a:solidFill>
+            <a:srgbClr val="FEF3C7"/>
+          </a:solidFill>
+          <a:ln>
+            <a:noFill/>
+          </a:ln>
+          <a:effectLst/>
+        </p:spPr>
+        <p:style>
+          <a:lnRef idx="1">
+            <a:schemeClr val="accent1"/>
+          </a:lnRef>
+          <a:fillRef idx="3">
+            <a:schemeClr val="accent1"/>
+          </a:fillRef>
+          <a:effectRef idx="2">
+            <a:schemeClr val="accent1"/>
+          </a:effectRef>
+          <a:fontRef idx="minor">
+            <a:schemeClr val="lt1"/>
+          </a:fontRef>
+        </p:style>
+        <p:txBody>
+          <a:bodyPr rtlCol="0" anchor="ctr" wrap="square" lIns="182880" tIns="0" bIns="0"/>
+          <a:lstStyle/>
+          <a:p>
+            <a:pPr algn="l">
+              <a:spcAft>
+                <a:spcPts val="0"/>
+              </a:spcAft>
+            </a:pPr>
+            <a:r>
+              <a:rPr sz="1400" b="1">
+                <a:solidFill>
+                  <a:srgbClr val="B45309"/>
+                </a:solidFill>
+                <a:latin typeface="Arial"/>
+                <a:ea typeface="Arial"/>
+                <a:cs typeface="Arial"/>
+              </a:rPr>
+              <a:t>vs fixed-radius alerts</a:t>
+            </a:r>
+          </a:p>
+        </p:txBody>
+      </p:sp>
+      <p:sp>
+        <p:nvSpPr>
+          <p:cNvPr id="13" name="Card"/>
           <p:cNvSpPr/>
           <p:nvPr/>
         </p:nvSpPr>
@@ -10081,13 +10063,13 @@
       </p:sp>
       <p:sp>
         <p:nvSpPr>
-          <p:cNvPr id="13" name="Icon"/>
+          <p:cNvPr id="14" name="Icon"/>
           <p:cNvSpPr/>
           <p:nvPr/>
         </p:nvSpPr>
         <p:spPr>
           <a:xfrm>
-            <a:off x="4658258" y="2377440"/>
+            <a:off x="4658258" y="2331720"/>
             <a:ext cx="640080" cy="640080"/>
           </a:xfrm>
           <a:prstGeom prst="ellipse">
@@ -10140,13 +10122,13 @@
       </p:sp>
       <p:sp>
         <p:nvSpPr>
-          <p:cNvPr id="14" name="Text"/>
+          <p:cNvPr id="15" name="Text"/>
           <p:cNvSpPr txBox="1"/>
           <p:nvPr/>
         </p:nvSpPr>
         <p:spPr>
           <a:xfrm>
-            <a:off x="4658258" y="3246120"/>
+            <a:off x="4658258" y="3154680"/>
             <a:ext cx="2875178" cy="320040"/>
           </a:xfrm>
           <a:prstGeom prst="rect">
@@ -10181,14 +10163,14 @@
       </p:sp>
       <p:sp>
         <p:nvSpPr>
-          <p:cNvPr id="15" name="Text"/>
+          <p:cNvPr id="16" name="Text"/>
           <p:cNvSpPr txBox="1"/>
           <p:nvPr/>
         </p:nvSpPr>
         <p:spPr>
           <a:xfrm>
-            <a:off x="4658258" y="3749039"/>
-            <a:ext cx="2875178" cy="1645920"/>
+            <a:off x="4658258" y="3611880"/>
+            <a:ext cx="2875178" cy="1280160"/>
           </a:xfrm>
           <a:prstGeom prst="rect">
             <a:avLst/>
@@ -10215,14 +10197,75 @@
                 <a:ea typeface="Arial"/>
                 <a:cs typeface="Arial"/>
               </a:rPr>
-              <a:t>The constable clears the queue before the siren</a:t>
-            </a:r>
-          </a:p>
-        </p:txBody>
-      </p:sp>
-      <p:sp>
-        <p:nvSpPr>
-          <p:cNvPr id="16" name="Card"/>
+              <a:t>Queue cleared before the siren</a:t>
+            </a:r>
+          </a:p>
+        </p:txBody>
+      </p:sp>
+      <p:sp>
+        <p:nvSpPr>
+          <p:cNvPr id="17" name="Versus chip"/>
+          <p:cNvSpPr/>
+          <p:nvPr/>
+        </p:nvSpPr>
+        <p:spPr>
+          <a:xfrm>
+            <a:off x="4658258" y="4937760"/>
+            <a:ext cx="2875178" cy="411480"/>
+          </a:xfrm>
+          <a:prstGeom prst="roundRect">
+            <a:avLst>
+              <a:gd name="adj" fmla="val 48888"/>
+            </a:avLst>
+          </a:prstGeom>
+          <a:solidFill>
+            <a:srgbClr val="FEF3C7"/>
+          </a:solidFill>
+          <a:ln>
+            <a:noFill/>
+          </a:ln>
+          <a:effectLst/>
+        </p:spPr>
+        <p:style>
+          <a:lnRef idx="1">
+            <a:schemeClr val="accent1"/>
+          </a:lnRef>
+          <a:fillRef idx="3">
+            <a:schemeClr val="accent1"/>
+          </a:fillRef>
+          <a:effectRef idx="2">
+            <a:schemeClr val="accent1"/>
+          </a:effectRef>
+          <a:fontRef idx="minor">
+            <a:schemeClr val="lt1"/>
+          </a:fontRef>
+        </p:style>
+        <p:txBody>
+          <a:bodyPr rtlCol="0" anchor="ctr" wrap="square" lIns="182880" tIns="0" bIns="0"/>
+          <a:lstStyle/>
+          <a:p>
+            <a:pPr algn="l">
+              <a:spcAft>
+                <a:spcPts val="0"/>
+              </a:spcAft>
+            </a:pPr>
+            <a:r>
+              <a:rPr sz="1400" b="1">
+                <a:solidFill>
+                  <a:srgbClr val="B45309"/>
+                </a:solidFill>
+                <a:latin typeface="Arial"/>
+                <a:ea typeface="Arial"/>
+                <a:cs typeface="Arial"/>
+              </a:rPr>
+              <a:t>vs manual green corridors</a:t>
+            </a:r>
+          </a:p>
+        </p:txBody>
+      </p:sp>
+      <p:sp>
+        <p:nvSpPr>
+          <p:cNvPr id="18" name="Card"/>
           <p:cNvSpPr/>
           <p:nvPr/>
         </p:nvSpPr>
@@ -10268,13 +10311,13 @@
       </p:sp>
       <p:sp>
         <p:nvSpPr>
-          <p:cNvPr id="17" name="Icon"/>
+          <p:cNvPr id="19" name="Icon"/>
           <p:cNvSpPr/>
           <p:nvPr/>
         </p:nvSpPr>
         <p:spPr>
           <a:xfrm>
-            <a:off x="8356396" y="2377440"/>
+            <a:off x="8356396" y="2331720"/>
             <a:ext cx="640080" cy="640080"/>
           </a:xfrm>
           <a:prstGeom prst="ellipse">
@@ -10327,13 +10370,13 @@
       </p:sp>
       <p:sp>
         <p:nvSpPr>
-          <p:cNvPr id="18" name="Text"/>
+          <p:cNvPr id="20" name="Text"/>
           <p:cNvSpPr txBox="1"/>
           <p:nvPr/>
         </p:nvSpPr>
         <p:spPr>
           <a:xfrm>
-            <a:off x="8356396" y="3246120"/>
+            <a:off x="8356396" y="3154680"/>
             <a:ext cx="2875178" cy="320040"/>
           </a:xfrm>
           <a:prstGeom prst="rect">
@@ -10368,14 +10411,14 @@
       </p:sp>
       <p:sp>
         <p:nvSpPr>
-          <p:cNvPr id="19" name="Text"/>
+          <p:cNvPr id="21" name="Text"/>
           <p:cNvSpPr txBox="1"/>
           <p:nvPr/>
         </p:nvSpPr>
         <p:spPr>
           <a:xfrm>
-            <a:off x="8356396" y="3749039"/>
-            <a:ext cx="2875178" cy="1645920"/>
+            <a:off x="8356396" y="3611880"/>
+            <a:ext cx="2875178" cy="1280160"/>
           </a:xfrm>
           <a:prstGeom prst="rect">
             <a:avLst/>
@@ -10402,7 +10445,68 @@
                 <a:ea typeface="Arial"/>
                 <a:cs typeface="Arial"/>
               </a:rPr>
-              <a:t>Rules decide, Gemini explains; no hardware needed</a:t>
+              <a:t>Rules decide, Gemini explains; no hardware</a:t>
+            </a:r>
+          </a:p>
+        </p:txBody>
+      </p:sp>
+      <p:sp>
+        <p:nvSpPr>
+          <p:cNvPr id="22" name="Versus chip"/>
+          <p:cNvSpPr/>
+          <p:nvPr/>
+        </p:nvSpPr>
+        <p:spPr>
+          <a:xfrm>
+            <a:off x="8356396" y="4937760"/>
+            <a:ext cx="2875178" cy="411480"/>
+          </a:xfrm>
+          <a:prstGeom prst="roundRect">
+            <a:avLst>
+              <a:gd name="adj" fmla="val 48888"/>
+            </a:avLst>
+          </a:prstGeom>
+          <a:solidFill>
+            <a:srgbClr val="2A2D33"/>
+          </a:solidFill>
+          <a:ln>
+            <a:noFill/>
+          </a:ln>
+          <a:effectLst/>
+        </p:spPr>
+        <p:style>
+          <a:lnRef idx="1">
+            <a:schemeClr val="accent1"/>
+          </a:lnRef>
+          <a:fillRef idx="3">
+            <a:schemeClr val="accent1"/>
+          </a:fillRef>
+          <a:effectRef idx="2">
+            <a:schemeClr val="accent1"/>
+          </a:effectRef>
+          <a:fontRef idx="minor">
+            <a:schemeClr val="lt1"/>
+          </a:fontRef>
+        </p:style>
+        <p:txBody>
+          <a:bodyPr rtlCol="0" anchor="ctr" wrap="square" lIns="182880" tIns="0" bIns="0"/>
+          <a:lstStyle/>
+          <a:p>
+            <a:pPr algn="l">
+              <a:spcAft>
+                <a:spcPts val="0"/>
+              </a:spcAft>
+            </a:pPr>
+            <a:r>
+              <a:rPr sz="1400" b="1">
+                <a:solidFill>
+                  <a:srgbClr val="F59E0B"/>
+                </a:solidFill>
+                <a:latin typeface="Arial"/>
+                <a:ea typeface="Arial"/>
+                <a:cs typeface="Arial"/>
+              </a:rPr>
+              <a:t>vs IR/GPS preemption</a:t>
             </a:r>
           </a:p>
         </p:txBody>
@@ -13597,7 +13701,7 @@
                 <a:ea typeface="Arial"/>
                 <a:cs typeface="Arial"/>
               </a:rPr>
-              <a:t>Spoken alert</a:t>
+              <a:t>PREPARE alert</a:t>
             </a:r>
           </a:p>
         </p:txBody>
@@ -13762,7 +13866,7 @@
                 <a:ea typeface="Arial"/>
                 <a:cs typeface="Arial"/>
               </a:rPr>
-              <a:t>Hospital brief</a:t>
+              <a:t>Hospital handover</a:t>
             </a:r>
           </a:p>
         </p:txBody>
@@ -14091,8 +14195,8 @@
         </p:blipFill>
         <p:spPr>
           <a:xfrm>
-            <a:off x="1266884" y="1920240"/>
-            <a:ext cx="9657925" cy="3794760"/>
+            <a:off x="1648812" y="1920240"/>
+            <a:ext cx="8894069" cy="3931920"/>
           </a:xfrm>
           <a:prstGeom prst="rect">
             <a:avLst/>
@@ -14107,7 +14211,7 @@
         </p:nvSpPr>
         <p:spPr>
           <a:xfrm>
-            <a:off x="640080" y="5897879"/>
+            <a:off x="640080" y="5989320"/>
             <a:ext cx="10911535" cy="365760"/>
           </a:xfrm>
           <a:prstGeom prst="rect">
@@ -14426,7 +14530,7 @@
         </p:nvSpPr>
         <p:spPr>
           <a:xfrm>
-            <a:off x="640080" y="2267711"/>
+            <a:off x="640080" y="2221991"/>
             <a:ext cx="219456" cy="219456"/>
           </a:xfrm>
           <a:prstGeom prst="ellipse">
@@ -14471,7 +14575,7 @@
         <p:spPr>
           <a:xfrm>
             <a:off x="1051560" y="2011679"/>
-            <a:ext cx="1920240" cy="731520"/>
+            <a:ext cx="1920240" cy="640080"/>
           </a:xfrm>
           <a:prstGeom prst="rect">
             <a:avLst/>
@@ -14498,7 +14602,7 @@
                 <a:ea typeface="Arial"/>
                 <a:cs typeface="Arial"/>
               </a:rPr>
-              <a:t>AI</a:t>
+              <a:t>AI &amp; language</a:t>
             </a:r>
           </a:p>
         </p:txBody>
@@ -14512,11 +14616,11 @@
         <p:spPr>
           <a:xfrm>
             <a:off x="3017520" y="2011679"/>
-            <a:ext cx="2722778" cy="731520"/>
+            <a:ext cx="2722778" cy="640080"/>
           </a:xfrm>
           <a:prstGeom prst="roundRect">
             <a:avLst>
-              <a:gd name="adj" fmla="val 12500"/>
+              <a:gd name="adj" fmla="val 14285"/>
             </a:avLst>
           </a:prstGeom>
           <a:solidFill>
@@ -14575,11 +14679,11 @@
         <p:spPr>
           <a:xfrm>
             <a:off x="5923178" y="2011679"/>
-            <a:ext cx="2722778" cy="731520"/>
+            <a:ext cx="2722778" cy="640080"/>
           </a:xfrm>
           <a:prstGeom prst="roundRect">
             <a:avLst>
-              <a:gd name="adj" fmla="val 12500"/>
+              <a:gd name="adj" fmla="val 14285"/>
             </a:avLst>
           </a:prstGeom>
           <a:solidFill>
@@ -14638,11 +14742,11 @@
         <p:spPr>
           <a:xfrm>
             <a:off x="8828836" y="2011679"/>
-            <a:ext cx="2722778" cy="731520"/>
+            <a:ext cx="2722778" cy="640080"/>
           </a:xfrm>
           <a:prstGeom prst="roundRect">
             <a:avLst>
-              <a:gd name="adj" fmla="val 12500"/>
+              <a:gd name="adj" fmla="val 14285"/>
             </a:avLst>
           </a:prstGeom>
           <a:solidFill>
@@ -14687,7 +14791,7 @@
                 <a:ea typeface="Arial"/>
                 <a:cs typeface="Arial"/>
               </a:rPr>
-              <a:t>BigQuery ML</a:t>
+              <a:t>Cloud Translation</a:t>
             </a:r>
           </a:p>
         </p:txBody>
@@ -14700,7 +14804,7 @@
         </p:nvSpPr>
         <p:spPr>
           <a:xfrm>
-            <a:off x="640080" y="3182111"/>
+            <a:off x="640080" y="3026663"/>
             <a:ext cx="219456" cy="219456"/>
           </a:xfrm>
           <a:prstGeom prst="ellipse">
@@ -14744,8 +14848,8 @@
         </p:nvSpPr>
         <p:spPr>
           <a:xfrm>
-            <a:off x="1051560" y="2926079"/>
-            <a:ext cx="1920240" cy="731520"/>
+            <a:off x="1051560" y="2816351"/>
+            <a:ext cx="1920240" cy="640080"/>
           </a:xfrm>
           <a:prstGeom prst="rect">
             <a:avLst/>
@@ -14772,7 +14876,7 @@
                 <a:ea typeface="Arial"/>
                 <a:cs typeface="Arial"/>
               </a:rPr>
-              <a:t>Run &amp; data</a:t>
+              <a:t>Maps &amp; speech</a:t>
             </a:r>
           </a:p>
         </p:txBody>
@@ -14785,12 +14889,12 @@
         </p:nvSpPr>
         <p:spPr>
           <a:xfrm>
-            <a:off x="3017520" y="2926079"/>
-            <a:ext cx="2722778" cy="731520"/>
+            <a:off x="3017520" y="2816351"/>
+            <a:ext cx="2722778" cy="640080"/>
           </a:xfrm>
           <a:prstGeom prst="roundRect">
             <a:avLst>
-              <a:gd name="adj" fmla="val 12500"/>
+              <a:gd name="adj" fmla="val 14285"/>
             </a:avLst>
           </a:prstGeom>
           <a:solidFill>
@@ -14835,7 +14939,7 @@
                 <a:ea typeface="Arial"/>
                 <a:cs typeface="Arial"/>
               </a:rPr>
-              <a:t>Cloud Run</a:t>
+              <a:t>Routes API</a:t>
             </a:r>
           </a:p>
         </p:txBody>
@@ -14848,12 +14952,12 @@
         </p:nvSpPr>
         <p:spPr>
           <a:xfrm>
-            <a:off x="5923178" y="2926079"/>
-            <a:ext cx="2722778" cy="731520"/>
+            <a:off x="5923178" y="2816351"/>
+            <a:ext cx="2722778" cy="640080"/>
           </a:xfrm>
           <a:prstGeom prst="roundRect">
             <a:avLst>
-              <a:gd name="adj" fmla="val 12500"/>
+              <a:gd name="adj" fmla="val 14285"/>
             </a:avLst>
           </a:prstGeom>
           <a:solidFill>
@@ -14898,7 +15002,7 @@
                 <a:ea typeface="Arial"/>
                 <a:cs typeface="Arial"/>
               </a:rPr>
-              <a:t>Firestore</a:t>
+              <a:t>Text-to-Speech</a:t>
             </a:r>
           </a:p>
         </p:txBody>
@@ -14911,12 +15015,12 @@
         </p:nvSpPr>
         <p:spPr>
           <a:xfrm>
-            <a:off x="8828836" y="2926079"/>
-            <a:ext cx="2722778" cy="731520"/>
+            <a:off x="8828836" y="2816351"/>
+            <a:ext cx="2722778" cy="640080"/>
           </a:xfrm>
           <a:prstGeom prst="roundRect">
             <a:avLst>
-              <a:gd name="adj" fmla="val 12500"/>
+              <a:gd name="adj" fmla="val 14285"/>
             </a:avLst>
           </a:prstGeom>
           <a:solidFill>
@@ -14961,7 +15065,7 @@
                 <a:ea typeface="Arial"/>
                 <a:cs typeface="Arial"/>
               </a:rPr>
-              <a:t>BigQuery</a:t>
+              <a:t>Cloud Storage</a:t>
             </a:r>
           </a:p>
         </p:txBody>
@@ -14974,7 +15078,7 @@
         </p:nvSpPr>
         <p:spPr>
           <a:xfrm>
-            <a:off x="640080" y="4096511"/>
+            <a:off x="640080" y="3831336"/>
             <a:ext cx="219456" cy="219456"/>
           </a:xfrm>
           <a:prstGeom prst="ellipse">
@@ -15018,8 +15122,8 @@
         </p:nvSpPr>
         <p:spPr>
           <a:xfrm>
-            <a:off x="1051560" y="3840479"/>
-            <a:ext cx="1920240" cy="731520"/>
+            <a:off x="1051560" y="3621024"/>
+            <a:ext cx="1920240" cy="640080"/>
           </a:xfrm>
           <a:prstGeom prst="rect">
             <a:avLst/>
@@ -15046,7 +15150,7 @@
                 <a:ea typeface="Arial"/>
                 <a:cs typeface="Arial"/>
               </a:rPr>
-              <a:t>Maps &amp; speech</a:t>
+              <a:t>Run &amp; data</a:t>
             </a:r>
           </a:p>
         </p:txBody>
@@ -15059,12 +15163,12 @@
         </p:nvSpPr>
         <p:spPr>
           <a:xfrm>
-            <a:off x="3017520" y="3840479"/>
-            <a:ext cx="2722778" cy="731520"/>
+            <a:off x="3017520" y="3621024"/>
+            <a:ext cx="2722778" cy="640080"/>
           </a:xfrm>
           <a:prstGeom prst="roundRect">
             <a:avLst>
-              <a:gd name="adj" fmla="val 12500"/>
+              <a:gd name="adj" fmla="val 14285"/>
             </a:avLst>
           </a:prstGeom>
           <a:solidFill>
@@ -15109,7 +15213,7 @@
                 <a:ea typeface="Arial"/>
                 <a:cs typeface="Arial"/>
               </a:rPr>
-              <a:t>Routes API</a:t>
+              <a:t>Cloud Run</a:t>
             </a:r>
           </a:p>
         </p:txBody>
@@ -15122,12 +15226,12 @@
         </p:nvSpPr>
         <p:spPr>
           <a:xfrm>
-            <a:off x="5923178" y="3840479"/>
-            <a:ext cx="2722778" cy="731520"/>
+            <a:off x="5923178" y="3621024"/>
+            <a:ext cx="2722778" cy="640080"/>
           </a:xfrm>
           <a:prstGeom prst="roundRect">
             <a:avLst>
-              <a:gd name="adj" fmla="val 12500"/>
+              <a:gd name="adj" fmla="val 14285"/>
             </a:avLst>
           </a:prstGeom>
           <a:solidFill>
@@ -15172,7 +15276,7 @@
                 <a:ea typeface="Arial"/>
                 <a:cs typeface="Arial"/>
               </a:rPr>
-              <a:t>Text-to-Speech</a:t>
+              <a:t>Firestore</a:t>
             </a:r>
           </a:p>
         </p:txBody>
@@ -15185,12 +15289,12 @@
         </p:nvSpPr>
         <p:spPr>
           <a:xfrm>
-            <a:off x="8828836" y="3840479"/>
-            <a:ext cx="2722778" cy="731520"/>
+            <a:off x="8828836" y="3621024"/>
+            <a:ext cx="2722778" cy="640080"/>
           </a:xfrm>
           <a:prstGeom prst="roundRect">
             <a:avLst>
-              <a:gd name="adj" fmla="val 12500"/>
+              <a:gd name="adj" fmla="val 14285"/>
             </a:avLst>
           </a:prstGeom>
           <a:solidFill>
@@ -15235,7 +15339,7 @@
                 <a:ea typeface="Arial"/>
                 <a:cs typeface="Arial"/>
               </a:rPr>
-              <a:t>Translation</a:t>
+              <a:t>BigQuery</a:t>
             </a:r>
           </a:p>
         </p:txBody>
@@ -15248,7 +15352,7 @@
         </p:nvSpPr>
         <p:spPr>
           <a:xfrm>
-            <a:off x="640080" y="5010912"/>
+            <a:off x="640080" y="4636008"/>
             <a:ext cx="219456" cy="219456"/>
           </a:xfrm>
           <a:prstGeom prst="ellipse">
@@ -15292,8 +15396,8 @@
         </p:nvSpPr>
         <p:spPr>
           <a:xfrm>
-            <a:off x="1051560" y="4754879"/>
-            <a:ext cx="1920240" cy="731520"/>
+            <a:off x="1051560" y="4425696"/>
+            <a:ext cx="1920240" cy="640080"/>
           </a:xfrm>
           <a:prstGeom prst="rect">
             <a:avLst/>
@@ -15333,12 +15437,12 @@
         </p:nvSpPr>
         <p:spPr>
           <a:xfrm>
-            <a:off x="3017520" y="4754879"/>
-            <a:ext cx="2722778" cy="731520"/>
+            <a:off x="3017520" y="4425696"/>
+            <a:ext cx="2722778" cy="640080"/>
           </a:xfrm>
           <a:prstGeom prst="roundRect">
             <a:avLst>
-              <a:gd name="adj" fmla="val 12500"/>
+              <a:gd name="adj" fmla="val 14285"/>
             </a:avLst>
           </a:prstGeom>
           <a:solidFill>
@@ -15396,12 +15500,12 @@
         </p:nvSpPr>
         <p:spPr>
           <a:xfrm>
-            <a:off x="5923178" y="4754879"/>
-            <a:ext cx="2722778" cy="731520"/>
+            <a:off x="5923178" y="4425696"/>
+            <a:ext cx="2722778" cy="640080"/>
           </a:xfrm>
           <a:prstGeom prst="roundRect">
             <a:avLst>
-              <a:gd name="adj" fmla="val 12500"/>
+              <a:gd name="adj" fmla="val 14285"/>
             </a:avLst>
           </a:prstGeom>
           <a:solidFill>
@@ -15459,12 +15563,12 @@
         </p:nvSpPr>
         <p:spPr>
           <a:xfrm>
-            <a:off x="8828836" y="4754879"/>
-            <a:ext cx="2722778" cy="731520"/>
+            <a:off x="8828836" y="4425696"/>
+            <a:ext cx="2722778" cy="640080"/>
           </a:xfrm>
           <a:prstGeom prst="roundRect">
             <a:avLst>
-              <a:gd name="adj" fmla="val 12500"/>
+              <a:gd name="adj" fmla="val 14285"/>
             </a:avLst>
           </a:prstGeom>
           <a:solidFill>
@@ -15516,24 +15620,47 @@
       </p:sp>
       <p:sp>
         <p:nvSpPr>
-          <p:cNvPr id="28" name="Text"/>
-          <p:cNvSpPr txBox="1"/>
-          <p:nvPr/>
-        </p:nvSpPr>
-        <p:spPr>
-          <a:xfrm>
-            <a:off x="640080" y="5760720"/>
-            <a:ext cx="10911535" cy="274320"/>
-          </a:xfrm>
-          <a:prstGeom prst="rect">
-            <a:avLst/>
-          </a:prstGeom>
-          <a:noFill/>
-        </p:spPr>
-        <p:txBody>
-          <a:bodyPr wrap="square" anchor="t" lIns="0" tIns="0" rIns="0" bIns="0">
-            <a:spAutoFit/>
-          </a:bodyPr>
+          <p:cNvPr id="28" name="BigQuery ML note"/>
+          <p:cNvSpPr/>
+          <p:nvPr/>
+        </p:nvSpPr>
+        <p:spPr>
+          <a:xfrm>
+            <a:off x="640080" y="5321807"/>
+            <a:ext cx="10911535" cy="640080"/>
+          </a:xfrm>
+          <a:prstGeom prst="roundRect">
+            <a:avLst>
+              <a:gd name="adj" fmla="val 14285"/>
+            </a:avLst>
+          </a:prstGeom>
+          <a:solidFill>
+            <a:srgbClr val="F5F6F7"/>
+          </a:solidFill>
+          <a:ln w="9525">
+            <a:solidFill>
+              <a:srgbClr val="9CA3AF"/>
+            </a:solidFill>
+            <a:prstDash val="dash"/>
+          </a:ln>
+          <a:effectLst/>
+        </p:spPr>
+        <p:style>
+          <a:lnRef idx="1">
+            <a:schemeClr val="accent1"/>
+          </a:lnRef>
+          <a:fillRef idx="3">
+            <a:schemeClr val="accent1"/>
+          </a:fillRef>
+          <a:effectRef idx="2">
+            <a:schemeClr val="accent1"/>
+          </a:effectRef>
+          <a:fontRef idx="minor">
+            <a:schemeClr val="lt1"/>
+          </a:fontRef>
+        </p:style>
+        <p:txBody>
+          <a:bodyPr rtlCol="0" anchor="ctr" wrap="square" lIns="228600" tIns="0" rIns="182880" bIns="0"/>
           <a:lstStyle/>
           <a:p>
             <a:pPr algn="l">
@@ -15542,15 +15669,26 @@
               </a:spcAft>
             </a:pPr>
             <a:r>
-              <a:rPr sz="1200" b="0">
-                <a:solidFill>
-                  <a:srgbClr val="6B7280"/>
-                </a:solidFill>
-                <a:latin typeface="Arial"/>
-                <a:ea typeface="Arial"/>
-                <a:cs typeface="Arial"/>
-              </a:rPr>
-              <a:t>Also: Storage, Scheduler, Logging</a:t>
+              <a:rPr sz="1600" b="1">
+                <a:solidFill>
+                  <a:srgbClr val="111111"/>
+                </a:solidFill>
+                <a:latin typeface="Arial"/>
+                <a:ea typeface="Arial"/>
+                <a:cs typeface="Arial"/>
+              </a:rPr>
+              <a:t>BigQuery ML  </a:t>
+            </a:r>
+            <a:r>
+              <a:rPr sz="1600" b="0">
+                <a:solidFill>
+                  <a:srgbClr val="374151"/>
+                </a:solidFill>
+                <a:latin typeface="Arial"/>
+                <a:ea typeface="Arial"/>
+                <a:cs typeface="Arial"/>
+              </a:rPr>
+              <a:t>pipeline in place; model retrained on peak rows before submission</a:t>
             </a:r>
           </a:p>
         </p:txBody>

</xml_diff>

<commit_message>
Host the submission deck on the live site
</commit_message>
<xml_diff>
--- a/deck/Green-Corridor-Deck.pptx
+++ b/deck/Green-Corridor-Deck.pptx
@@ -7338,11 +7338,11 @@
         <p:spPr>
           <a:xfrm>
             <a:off x="640080" y="2011679"/>
-            <a:ext cx="3454298" cy="4023360"/>
+            <a:ext cx="2522143" cy="4023360"/>
           </a:xfrm>
           <a:prstGeom prst="roundRect">
             <a:avLst>
-              <a:gd name="adj" fmla="val 3705"/>
+              <a:gd name="adj" fmla="val 5075"/>
             </a:avLst>
           </a:prstGeom>
           <a:solidFill>
@@ -7386,7 +7386,7 @@
         <p:spPr>
           <a:xfrm>
             <a:off x="914400" y="2240279"/>
-            <a:ext cx="2905658" cy="274320"/>
+            <a:ext cx="1973503" cy="274320"/>
           </a:xfrm>
           <a:prstGeom prst="rect">
             <a:avLst/>
@@ -7436,8 +7436,8 @@
         </p:blipFill>
         <p:spPr>
           <a:xfrm>
-            <a:off x="1178509" y="2697480"/>
-            <a:ext cx="2377440" cy="2377440"/>
+            <a:off x="895311" y="2697480"/>
+            <a:ext cx="2011680" cy="2011680"/>
           </a:xfrm>
           <a:prstGeom prst="rect">
             <a:avLst/>
@@ -7452,8 +7452,8 @@
         </p:nvSpPr>
         <p:spPr>
           <a:xfrm>
-            <a:off x="822959" y="5303520"/>
-            <a:ext cx="3088538" cy="365760"/>
+            <a:off x="777240" y="4983479"/>
+            <a:ext cx="2247823" cy="731520"/>
           </a:xfrm>
           <a:prstGeom prst="rect">
             <a:avLst/>
@@ -7472,7 +7472,7 @@
               </a:spcAft>
             </a:pPr>
             <a:r>
-              <a:rPr sz="1400" b="1">
+              <a:rPr sz="1200" b="1">
                 <a:solidFill>
                   <a:srgbClr val="111111"/>
                 </a:solidFill>
@@ -7493,12 +7493,12 @@
         </p:nvSpPr>
         <p:spPr>
           <a:xfrm>
-            <a:off x="4368698" y="2011679"/>
-            <a:ext cx="3454298" cy="4023360"/>
+            <a:off x="3436543" y="2011679"/>
+            <a:ext cx="2522143" cy="4023360"/>
           </a:xfrm>
           <a:prstGeom prst="roundRect">
             <a:avLst>
-              <a:gd name="adj" fmla="val 3705"/>
+              <a:gd name="adj" fmla="val 5075"/>
             </a:avLst>
           </a:prstGeom>
           <a:solidFill>
@@ -7542,8 +7542,8 @@
         </p:nvSpPr>
         <p:spPr>
           <a:xfrm>
-            <a:off x="4643018" y="2240279"/>
-            <a:ext cx="2905658" cy="274320"/>
+            <a:off x="3710863" y="2240279"/>
+            <a:ext cx="1973503" cy="274320"/>
           </a:xfrm>
           <a:prstGeom prst="rect">
             <a:avLst/>
@@ -7583,8 +7583,8 @@
         </p:nvSpPr>
         <p:spPr>
           <a:xfrm>
-            <a:off x="4643018" y="3246120"/>
-            <a:ext cx="2905658" cy="1280160"/>
+            <a:off x="3710863" y="3246120"/>
+            <a:ext cx="1973503" cy="1280160"/>
           </a:xfrm>
           <a:prstGeom prst="rect">
             <a:avLst/>
@@ -7603,7 +7603,7 @@
               </a:spcAft>
             </a:pPr>
             <a:r>
-              <a:rPr sz="2800" b="1">
+              <a:rPr sz="2200" b="1">
                 <a:solidFill>
                   <a:srgbClr val="6B7280"/>
                 </a:solidFill>
@@ -7624,12 +7624,12 @@
         </p:nvSpPr>
         <p:spPr>
           <a:xfrm>
-            <a:off x="8097316" y="2011679"/>
-            <a:ext cx="3454298" cy="4023360"/>
+            <a:off x="6233007" y="2011679"/>
+            <a:ext cx="2522143" cy="4023360"/>
           </a:xfrm>
           <a:prstGeom prst="roundRect">
             <a:avLst>
-              <a:gd name="adj" fmla="val 3705"/>
+              <a:gd name="adj" fmla="val 5075"/>
             </a:avLst>
           </a:prstGeom>
           <a:solidFill>
@@ -7672,8 +7672,8 @@
         </p:nvSpPr>
         <p:spPr>
           <a:xfrm>
-            <a:off x="8371636" y="2240279"/>
-            <a:ext cx="2905658" cy="274320"/>
+            <a:off x="6507327" y="2240279"/>
+            <a:ext cx="1973503" cy="274320"/>
           </a:xfrm>
           <a:prstGeom prst="rect">
             <a:avLst/>
@@ -7723,8 +7723,8 @@
         </p:blipFill>
         <p:spPr>
           <a:xfrm>
-            <a:off x="8635746" y="2697480"/>
-            <a:ext cx="2377440" cy="2377440"/>
+            <a:off x="6488239" y="2697480"/>
+            <a:ext cx="2011680" cy="2011680"/>
           </a:xfrm>
           <a:prstGeom prst="rect">
             <a:avLst/>
@@ -7739,8 +7739,8 @@
         </p:nvSpPr>
         <p:spPr>
           <a:xfrm>
-            <a:off x="8280196" y="5303520"/>
-            <a:ext cx="3088538" cy="365760"/>
+            <a:off x="6370167" y="4983479"/>
+            <a:ext cx="2247823" cy="731520"/>
           </a:xfrm>
           <a:prstGeom prst="rect">
             <a:avLst/>
@@ -7759,7 +7759,7 @@
               </a:spcAft>
             </a:pPr>
             <a:r>
-              <a:rPr sz="1400" b="1">
+              <a:rPr sz="1200" b="1">
                 <a:solidFill>
                   <a:srgbClr val="111111"/>
                 </a:solidFill>
@@ -7768,6 +7768,162 @@
                 <a:cs typeface="Arial"/>
               </a:rPr>
               <a:t>green-corridor-2026.web.app</a:t>
+            </a:r>
+          </a:p>
+        </p:txBody>
+      </p:sp>
+      <p:sp>
+        <p:nvSpPr>
+          <p:cNvPr id="19" name="Link tile"/>
+          <p:cNvSpPr/>
+          <p:nvPr/>
+        </p:nvSpPr>
+        <p:spPr>
+          <a:xfrm>
+            <a:off x="9029471" y="2011679"/>
+            <a:ext cx="2522143" cy="4023360"/>
+          </a:xfrm>
+          <a:prstGeom prst="roundRect">
+            <a:avLst>
+              <a:gd name="adj" fmla="val 5075"/>
+            </a:avLst>
+          </a:prstGeom>
+          <a:solidFill>
+            <a:srgbClr val="FFFFFF"/>
+          </a:solidFill>
+          <a:ln w="9525">
+            <a:solidFill>
+              <a:srgbClr val="D9DADD"/>
+            </a:solidFill>
+          </a:ln>
+          <a:effectLst/>
+        </p:spPr>
+        <p:style>
+          <a:lnRef idx="1">
+            <a:schemeClr val="accent1"/>
+          </a:lnRef>
+          <a:fillRef idx="3">
+            <a:schemeClr val="accent1"/>
+          </a:fillRef>
+          <a:effectRef idx="2">
+            <a:schemeClr val="accent1"/>
+          </a:effectRef>
+          <a:fontRef idx="minor">
+            <a:schemeClr val="lt1"/>
+          </a:fontRef>
+        </p:style>
+        <p:txBody>
+          <a:bodyPr rtlCol="0" anchor="ctr"/>
+          <a:lstStyle/>
+          <a:p>
+            <a:pPr algn="ctr"/>
+          </a:p>
+        </p:txBody>
+      </p:sp>
+      <p:sp>
+        <p:nvSpPr>
+          <p:cNvPr id="20" name="Text"/>
+          <p:cNvSpPr txBox="1"/>
+          <p:nvPr/>
+        </p:nvSpPr>
+        <p:spPr>
+          <a:xfrm>
+            <a:off x="9303791" y="2240279"/>
+            <a:ext cx="1973503" cy="274320"/>
+          </a:xfrm>
+          <a:prstGeom prst="rect">
+            <a:avLst/>
+          </a:prstGeom>
+          <a:noFill/>
+        </p:spPr>
+        <p:txBody>
+          <a:bodyPr wrap="square" anchor="t" lIns="0" tIns="0" rIns="0" bIns="0">
+            <a:spAutoFit/>
+          </a:bodyPr>
+          <a:lstStyle/>
+          <a:p>
+            <a:pPr algn="l">
+              <a:spcAft>
+                <a:spcPts val="0"/>
+              </a:spcAft>
+            </a:pPr>
+            <a:r>
+              <a:rPr sz="1200" b="1" cap="all" spc="80">
+                <a:solidFill>
+                  <a:srgbClr val="6B7280"/>
+                </a:solidFill>
+                <a:latin typeface="Arial"/>
+                <a:ea typeface="Arial"/>
+                <a:cs typeface="Arial"/>
+              </a:rPr>
+              <a:t>Submission deck</a:t>
+            </a:r>
+          </a:p>
+        </p:txBody>
+      </p:sp>
+      <p:pic>
+        <p:nvPicPr>
+          <p:cNvPr id="21" name="QR" descr="image.png">
+            <a:hlinkClick r:id="rId7"/>
+          </p:cNvPr>
+          <p:cNvPicPr>
+            <a:picLocks noChangeAspect="1"/>
+          </p:cNvPicPr>
+          <p:nvPr/>
+        </p:nvPicPr>
+        <p:blipFill>
+          <a:blip r:embed="rId6"/>
+          <a:stretch>
+            <a:fillRect/>
+          </a:stretch>
+        </p:blipFill>
+        <p:spPr>
+          <a:xfrm>
+            <a:off x="9284703" y="2697480"/>
+            <a:ext cx="2011680" cy="2011680"/>
+          </a:xfrm>
+          <a:prstGeom prst="rect">
+            <a:avLst/>
+          </a:prstGeom>
+        </p:spPr>
+      </p:pic>
+      <p:sp>
+        <p:nvSpPr>
+          <p:cNvPr id="22" name="Text"/>
+          <p:cNvSpPr txBox="1"/>
+          <p:nvPr/>
+        </p:nvSpPr>
+        <p:spPr>
+          <a:xfrm>
+            <a:off x="9166631" y="4983479"/>
+            <a:ext cx="2247823" cy="731520"/>
+          </a:xfrm>
+          <a:prstGeom prst="rect">
+            <a:avLst/>
+          </a:prstGeom>
+          <a:noFill/>
+        </p:spPr>
+        <p:txBody>
+          <a:bodyPr wrap="square" anchor="t" lIns="0" tIns="0" rIns="0" bIns="0">
+            <a:spAutoFit/>
+          </a:bodyPr>
+          <a:lstStyle/>
+          <a:p>
+            <a:pPr algn="ctr">
+              <a:spcAft>
+                <a:spcPts val="0"/>
+              </a:spcAft>
+            </a:pPr>
+            <a:r>
+              <a:rPr sz="1200" b="1">
+                <a:solidFill>
+                  <a:srgbClr val="111111"/>
+                </a:solidFill>
+                <a:latin typeface="Arial"/>
+                <a:ea typeface="Arial"/>
+                <a:cs typeface="Arial"/>
+              </a:rPr>
+              <a:t>green-corridor-2026.web.app/deck.pdf</a:t>
             </a:r>
           </a:p>
         </p:txBody>

</xml_diff>

<commit_message>
Deck: sustainability slide; stale text sweep
</commit_message>
<xml_diff>
--- a/deck/Green-Corridor-Deck.pptx
+++ b/deck/Green-Corridor-Deck.pptx
@@ -21,6 +21,7 @@
     <p:sldId id="269" r:id="rId20"/>
     <p:sldId id="270" r:id="rId21"/>
     <p:sldId id="271" r:id="rId22"/>
+    <p:sldId id="272" r:id="rId23"/>
   </p:sldIdLst>
   <p:sldSz cx="12191695" cy="6858000" type="screen4x3"/>
   <p:notesSz cx="6858000" cy="9144000"/>
@@ -3693,7 +3694,7 @@
                 <a:ea typeface="Arial"/>
                 <a:cs typeface="Arial"/>
               </a:rPr>
-              <a:t>10 / 16</a:t>
+              <a:t>10 / 17</a:t>
             </a:r>
           </a:p>
         </p:txBody>
@@ -4735,7 +4736,7 @@
                 <a:ea typeface="Arial"/>
                 <a:cs typeface="Arial"/>
               </a:rPr>
-              <a:t>11 / 16</a:t>
+              <a:t>11 / 17</a:t>
             </a:r>
           </a:p>
         </p:txBody>
@@ -5244,7 +5245,7 @@
                 <a:ea typeface="Arial"/>
                 <a:cs typeface="Arial"/>
               </a:rPr>
-              <a:t>12 / 16</a:t>
+              <a:t>12 / 17</a:t>
             </a:r>
           </a:p>
         </p:txBody>
@@ -5823,7 +5824,7 @@
                 <a:ea typeface="Arial"/>
                 <a:cs typeface="Arial"/>
               </a:rPr>
-              <a:t>13 / 16</a:t>
+              <a:t>13 / 17</a:t>
             </a:r>
           </a:p>
         </p:txBody>
@@ -6134,7 +6135,7 @@
                 <a:ea typeface="Arial"/>
                 <a:cs typeface="Arial"/>
               </a:rPr>
-              <a:t>11 synthetic clips, the ones the fix targeted; real clips pending. Before the fix: 87 % / 73 %.</a:t>
+              <a:t>12 synthetic clips, 11 scored for tier, 1 intervention note; not field recordings. Before the fix: 87 % / 73 %.</a:t>
             </a:r>
           </a:p>
         </p:txBody>
@@ -6285,7 +6286,7 @@
                 <a:ea typeface="Arial"/>
                 <a:cs typeface="Arial"/>
               </a:rPr>
-              <a:t>344</a:t>
+              <a:t>349</a:t>
             </a:r>
             <a:r>
               <a:rPr sz="1800" b="0">
@@ -6307,7 +6308,7 @@
                 <a:ea typeface="Arial"/>
                 <a:cs typeface="Arial"/>
               </a:rPr>
-              <a:t>138</a:t>
+              <a:t>147</a:t>
             </a:r>
             <a:r>
               <a:rPr sz="1800" b="0">
@@ -6614,7 +6615,7 @@
                 <a:ea typeface="Arial"/>
                 <a:cs typeface="Arial"/>
               </a:rPr>
-              <a:t>14 / 16</a:t>
+              <a:t>14 / 17</a:t>
             </a:r>
           </a:p>
         </p:txBody>
@@ -7165,7 +7166,7 @@
                 <a:ea typeface="Arial"/>
                 <a:cs typeface="Arial"/>
               </a:rPr>
-              <a:t>Links</a:t>
+              <a:t>Sustainability</a:t>
             </a:r>
           </a:p>
         </p:txBody>
@@ -7242,7 +7243,7 @@
                 <a:ea typeface="Arial"/>
                 <a:cs typeface="Arial"/>
               </a:rPr>
-              <a:t>Try it, read the code, watch the demo</a:t>
+              <a:t>We size the green to the queue, so cross-traffic idling is bounded by the clearance time.</a:t>
             </a:r>
           </a:p>
         </p:txBody>
@@ -7283,7 +7284,7 @@
                 <a:ea typeface="Arial"/>
                 <a:cs typeface="Arial"/>
               </a:rPr>
-              <a:t>Green Corridor · Links</a:t>
+              <a:t>Green Corridor · Sustainability</a:t>
             </a:r>
           </a:p>
         </p:txBody>
@@ -7324,7 +7325,574 @@
                 <a:ea typeface="Arial"/>
                 <a:cs typeface="Arial"/>
               </a:rPr>
-              <a:t>15 / 16</a:t>
+              <a:t>15 / 17</a:t>
+            </a:r>
+          </a:p>
+        </p:txBody>
+      </p:sp>
+      <p:sp>
+        <p:nvSpPr>
+          <p:cNvPr id="8" name="Stat tile"/>
+          <p:cNvSpPr/>
+          <p:nvPr/>
+        </p:nvSpPr>
+        <p:spPr>
+          <a:xfrm>
+            <a:off x="640080" y="2057400"/>
+            <a:ext cx="3515258" cy="2743200"/>
+          </a:xfrm>
+          <a:prstGeom prst="roundRect">
+            <a:avLst>
+              <a:gd name="adj" fmla="val 4666"/>
+            </a:avLst>
+          </a:prstGeom>
+          <a:solidFill>
+            <a:srgbClr val="F59E0B"/>
+          </a:solidFill>
+          <a:ln>
+            <a:noFill/>
+          </a:ln>
+          <a:effectLst/>
+        </p:spPr>
+        <p:style>
+          <a:lnRef idx="1">
+            <a:schemeClr val="accent1"/>
+          </a:lnRef>
+          <a:fillRef idx="3">
+            <a:schemeClr val="accent1"/>
+          </a:fillRef>
+          <a:effectRef idx="2">
+            <a:schemeClr val="accent1"/>
+          </a:effectRef>
+          <a:fontRef idx="minor">
+            <a:schemeClr val="lt1"/>
+          </a:fontRef>
+        </p:style>
+        <p:txBody>
+          <a:bodyPr rtlCol="0" anchor="ctr" wrap="square" lIns="274320" tIns="91440" rIns="228600" bIns="91440"/>
+          <a:lstStyle/>
+          <a:p>
+            <a:pPr algn="l">
+              <a:spcAft>
+                <a:spcPts val="400"/>
+              </a:spcAft>
+            </a:pPr>
+            <a:r>
+              <a:rPr sz="5400" b="1">
+                <a:solidFill>
+                  <a:srgbClr val="111111"/>
+                </a:solidFill>
+                <a:latin typeface="Arial"/>
+                <a:ea typeface="Arial"/>
+                <a:cs typeface="Arial"/>
+              </a:rPr>
+              <a:t>0.25</a:t>
+            </a:r>
+            <a:r>
+              <a:rPr sz="2200" b="1">
+                <a:solidFill>
+                  <a:srgbClr val="111111"/>
+                </a:solidFill>
+                <a:latin typeface="Arial"/>
+                <a:ea typeface="Arial"/>
+                <a:cs typeface="Arial"/>
+              </a:rPr>
+              <a:t> L</a:t>
+            </a:r>
+          </a:p>
+          <a:p>
+            <a:pPr algn="l">
+              <a:spcAft>
+                <a:spcPts val="400"/>
+              </a:spcAft>
+            </a:pPr>
+            <a:r>
+              <a:rPr sz="1600" b="0">
+                <a:solidFill>
+                  <a:srgbClr val="111111"/>
+                </a:solidFill>
+                <a:latin typeface="Arial"/>
+                <a:ea typeface="Arial"/>
+                <a:cs typeface="Arial"/>
+              </a:rPr>
+              <a:t>idling fuel avoided per cleared queue (illustration: 20 vehicles × 60 s × 0.76 L/h)</a:t>
+            </a:r>
+          </a:p>
+        </p:txBody>
+      </p:sp>
+      <p:sp>
+        <p:nvSpPr>
+          <p:cNvPr id="9" name="Stat tile"/>
+          <p:cNvSpPr/>
+          <p:nvPr/>
+        </p:nvSpPr>
+        <p:spPr>
+          <a:xfrm>
+            <a:off x="4338218" y="2057400"/>
+            <a:ext cx="3515258" cy="2743200"/>
+          </a:xfrm>
+          <a:prstGeom prst="roundRect">
+            <a:avLst>
+              <a:gd name="adj" fmla="val 4666"/>
+            </a:avLst>
+          </a:prstGeom>
+          <a:solidFill>
+            <a:srgbClr val="14171B"/>
+          </a:solidFill>
+          <a:ln>
+            <a:noFill/>
+          </a:ln>
+          <a:effectLst/>
+        </p:spPr>
+        <p:style>
+          <a:lnRef idx="1">
+            <a:schemeClr val="accent1"/>
+          </a:lnRef>
+          <a:fillRef idx="3">
+            <a:schemeClr val="accent1"/>
+          </a:fillRef>
+          <a:effectRef idx="2">
+            <a:schemeClr val="accent1"/>
+          </a:effectRef>
+          <a:fontRef idx="minor">
+            <a:schemeClr val="lt1"/>
+          </a:fontRef>
+        </p:style>
+        <p:txBody>
+          <a:bodyPr rtlCol="0" anchor="ctr" wrap="square" lIns="274320" tIns="91440" rIns="228600" bIns="91440"/>
+          <a:lstStyle/>
+          <a:p>
+            <a:pPr algn="l">
+              <a:spcAft>
+                <a:spcPts val="400"/>
+              </a:spcAft>
+            </a:pPr>
+            <a:r>
+              <a:rPr sz="5400" b="1">
+                <a:solidFill>
+                  <a:srgbClr val="F59E0B"/>
+                </a:solidFill>
+                <a:latin typeface="Arial"/>
+                <a:ea typeface="Arial"/>
+                <a:cs typeface="Arial"/>
+              </a:rPr>
+              <a:t>2.35</a:t>
+            </a:r>
+            <a:r>
+              <a:rPr sz="2200" b="1">
+                <a:solidFill>
+                  <a:srgbClr val="F59E0B"/>
+                </a:solidFill>
+                <a:latin typeface="Arial"/>
+                <a:ea typeface="Arial"/>
+                <a:cs typeface="Arial"/>
+              </a:rPr>
+              <a:t> kg</a:t>
+            </a:r>
+          </a:p>
+          <a:p>
+            <a:pPr algn="l">
+              <a:spcAft>
+                <a:spcPts val="400"/>
+              </a:spcAft>
+            </a:pPr>
+            <a:r>
+              <a:rPr sz="1600" b="0">
+                <a:solidFill>
+                  <a:srgbClr val="E5E7EB"/>
+                </a:solidFill>
+                <a:latin typeface="Arial"/>
+                <a:ea typeface="Arial"/>
+                <a:cs typeface="Arial"/>
+              </a:rPr>
+              <a:t>CO₂ per litre of petrol (EPA)</a:t>
+            </a:r>
+          </a:p>
+        </p:txBody>
+      </p:sp>
+      <p:sp>
+        <p:nvSpPr>
+          <p:cNvPr id="10" name="Stat tile"/>
+          <p:cNvSpPr/>
+          <p:nvPr/>
+        </p:nvSpPr>
+        <p:spPr>
+          <a:xfrm>
+            <a:off x="8036356" y="2057400"/>
+            <a:ext cx="3515258" cy="2743200"/>
+          </a:xfrm>
+          <a:prstGeom prst="roundRect">
+            <a:avLst>
+              <a:gd name="adj" fmla="val 4666"/>
+            </a:avLst>
+          </a:prstGeom>
+          <a:solidFill>
+            <a:srgbClr val="14171B"/>
+          </a:solidFill>
+          <a:ln>
+            <a:noFill/>
+          </a:ln>
+          <a:effectLst/>
+        </p:spPr>
+        <p:style>
+          <a:lnRef idx="1">
+            <a:schemeClr val="accent1"/>
+          </a:lnRef>
+          <a:fillRef idx="3">
+            <a:schemeClr val="accent1"/>
+          </a:fillRef>
+          <a:effectRef idx="2">
+            <a:schemeClr val="accent1"/>
+          </a:effectRef>
+          <a:fontRef idx="minor">
+            <a:schemeClr val="lt1"/>
+          </a:fontRef>
+        </p:style>
+        <p:txBody>
+          <a:bodyPr rtlCol="0" anchor="ctr" wrap="square" lIns="274320" tIns="91440" rIns="228600" bIns="91440"/>
+          <a:lstStyle/>
+          <a:p>
+            <a:pPr algn="l">
+              <a:spcAft>
+                <a:spcPts val="400"/>
+              </a:spcAft>
+            </a:pPr>
+            <a:r>
+              <a:rPr sz="2800" b="1">
+                <a:solidFill>
+                  <a:srgbClr val="F59E0B"/>
+                </a:solidFill>
+                <a:latin typeface="Arial"/>
+                <a:ea typeface="Arial"/>
+                <a:cs typeface="Arial"/>
+              </a:rPr>
+              <a:t>SDG 3.8 · 11.2</a:t>
+            </a:r>
+          </a:p>
+          <a:p>
+            <a:pPr algn="l">
+              <a:spcAft>
+                <a:spcPts val="400"/>
+              </a:spcAft>
+            </a:pPr>
+            <a:r>
+              <a:rPr sz="1600" b="0">
+                <a:solidFill>
+                  <a:srgbClr val="E5E7EB"/>
+                </a:solidFill>
+                <a:latin typeface="Arial"/>
+                <a:ea typeface="Arial"/>
+                <a:cs typeface="Arial"/>
+              </a:rPr>
+              <a:t>emergency care access · sustainable transport</a:t>
+            </a:r>
+          </a:p>
+        </p:txBody>
+      </p:sp>
+      <p:sp>
+        <p:nvSpPr>
+          <p:cNvPr id="11" name="Figure citation"/>
+          <p:cNvSpPr txBox="1"/>
+          <p:nvPr/>
+        </p:nvSpPr>
+        <p:spPr>
+          <a:xfrm>
+            <a:off x="640080" y="5074920"/>
+            <a:ext cx="10911535" cy="640080"/>
+          </a:xfrm>
+          <a:prstGeom prst="rect">
+            <a:avLst/>
+          </a:prstGeom>
+          <a:noFill/>
+        </p:spPr>
+        <p:txBody>
+          <a:bodyPr wrap="square" anchor="t" lIns="0" tIns="0" rIns="0" bIns="0">
+            <a:spAutoFit/>
+          </a:bodyPr>
+          <a:lstStyle/>
+          <a:p>
+            <a:pPr algn="l">
+              <a:spcAft>
+                <a:spcPts val="0"/>
+              </a:spcAft>
+            </a:pPr>
+            <a:r>
+              <a:rPr sz="1100" b="0">
+                <a:solidFill>
+                  <a:srgbClr val="6B7280"/>
+                </a:solidFill>
+                <a:latin typeface="Arial"/>
+                <a:ea typeface="Arial"/>
+                <a:cs typeface="Arial"/>
+              </a:rPr>
+              <a:t>Idle burn: Argonne National Laboratory (Gaines, Rask, Keller), US DOE, 2014. CO₂: US EPA, GHG Equivalencies Calculator, 2024. The per-queue arithmetic is an illustration, not a measurement or a net saving.</a:t>
+            </a:r>
+          </a:p>
+        </p:txBody>
+      </p:sp>
+    </p:spTree>
+  </p:cSld>
+  <p:clrMapOvr>
+    <a:masterClrMapping/>
+  </p:clrMapOvr>
+</p:sld>
+</file>
+
+<file path=ppt/slides/slide16.xml><?xml version="1.0" encoding="utf-8"?>
+<p:sld xmlns:a="http://schemas.openxmlformats.org/drawingml/2006/main" xmlns:p="http://schemas.openxmlformats.org/presentationml/2006/main" xmlns:r="http://schemas.openxmlformats.org/officeDocument/2006/relationships">
+  <p:cSld>
+    <p:bg>
+      <p:bgPr>
+        <a:solidFill>
+          <a:srgbClr val="FFFFFF"/>
+        </a:solidFill>
+        <a:effectLst/>
+      </p:bgPr>
+    </p:bg>
+    <p:spTree>
+      <p:nvGrpSpPr>
+        <p:cNvPr id="1" name=""/>
+        <p:cNvGrpSpPr/>
+        <p:nvPr/>
+      </p:nvGrpSpPr>
+      <p:grpSpPr/>
+      <p:sp>
+        <p:nvSpPr>
+          <p:cNvPr id="2" name="Masthead eyebrow"/>
+          <p:cNvSpPr txBox="1"/>
+          <p:nvPr/>
+        </p:nvSpPr>
+        <p:spPr>
+          <a:xfrm>
+            <a:off x="640080" y="365760"/>
+            <a:ext cx="10911535" cy="228600"/>
+          </a:xfrm>
+          <a:prstGeom prst="rect">
+            <a:avLst/>
+          </a:prstGeom>
+          <a:noFill/>
+        </p:spPr>
+        <p:txBody>
+          <a:bodyPr wrap="square" anchor="t" lIns="0" tIns="0" rIns="0" bIns="0">
+            <a:spAutoFit/>
+          </a:bodyPr>
+          <a:lstStyle/>
+          <a:p>
+            <a:pPr algn="l">
+              <a:spcAft>
+                <a:spcPts val="0"/>
+              </a:spcAft>
+            </a:pPr>
+            <a:r>
+              <a:rPr sz="1100" b="1" cap="all" spc="120">
+                <a:solidFill>
+                  <a:srgbClr val="B45309"/>
+                </a:solidFill>
+                <a:latin typeface="Arial"/>
+                <a:ea typeface="Arial"/>
+                <a:cs typeface="Arial"/>
+              </a:rPr>
+              <a:t>Google Cloud AI Builder Cup 2026 · Sustainability &amp; Social Impact</a:t>
+            </a:r>
+          </a:p>
+        </p:txBody>
+      </p:sp>
+      <p:sp>
+        <p:nvSpPr>
+          <p:cNvPr id="3" name="Title"/>
+          <p:cNvSpPr txBox="1"/>
+          <p:nvPr/>
+        </p:nvSpPr>
+        <p:spPr>
+          <a:xfrm>
+            <a:off x="640080" y="640080"/>
+            <a:ext cx="10911535" cy="566928"/>
+          </a:xfrm>
+          <a:prstGeom prst="rect">
+            <a:avLst/>
+          </a:prstGeom>
+          <a:noFill/>
+        </p:spPr>
+        <p:txBody>
+          <a:bodyPr wrap="square" anchor="ctr" lIns="0" tIns="0" rIns="0" bIns="0">
+            <a:spAutoFit/>
+          </a:bodyPr>
+          <a:lstStyle/>
+          <a:p>
+            <a:pPr algn="l">
+              <a:spcAft>
+                <a:spcPts val="0"/>
+              </a:spcAft>
+            </a:pPr>
+            <a:r>
+              <a:rPr sz="3400" b="1">
+                <a:solidFill>
+                  <a:srgbClr val="111111"/>
+                </a:solidFill>
+                <a:latin typeface="Arial"/>
+                <a:ea typeface="Arial"/>
+                <a:cs typeface="Arial"/>
+              </a:rPr>
+              <a:t>Links</a:t>
+            </a:r>
+          </a:p>
+        </p:txBody>
+      </p:sp>
+      <p:cxnSp>
+        <p:nvCxnSpPr>
+          <p:cNvPr id="4" name="Masthead rule"/>
+          <p:cNvCxnSpPr/>
+          <p:nvPr/>
+        </p:nvCxnSpPr>
+        <p:spPr>
+          <a:xfrm>
+            <a:off x="640080" y="1280160"/>
+            <a:ext cx="10911535" cy="0"/>
+          </a:xfrm>
+          <a:prstGeom prst="line">
+            <a:avLst/>
+          </a:prstGeom>
+          <a:ln w="15875">
+            <a:solidFill>
+              <a:srgbClr val="F59E0B"/>
+            </a:solidFill>
+          </a:ln>
+          <a:effectLst/>
+        </p:spPr>
+        <p:style>
+          <a:lnRef idx="2">
+            <a:schemeClr val="accent1"/>
+          </a:lnRef>
+          <a:fillRef idx="0">
+            <a:schemeClr val="accent1"/>
+          </a:fillRef>
+          <a:effectRef idx="1">
+            <a:schemeClr val="accent1"/>
+          </a:effectRef>
+          <a:fontRef idx="minor">
+            <a:schemeClr val="tx1"/>
+          </a:fontRef>
+        </p:style>
+      </p:cxnSp>
+      <p:sp>
+        <p:nvSpPr>
+          <p:cNvPr id="5" name="Lede"/>
+          <p:cNvSpPr txBox="1"/>
+          <p:nvPr/>
+        </p:nvSpPr>
+        <p:spPr>
+          <a:xfrm>
+            <a:off x="640080" y="1389888"/>
+            <a:ext cx="10911535" cy="365760"/>
+          </a:xfrm>
+          <a:prstGeom prst="rect">
+            <a:avLst/>
+          </a:prstGeom>
+          <a:noFill/>
+        </p:spPr>
+        <p:txBody>
+          <a:bodyPr wrap="square" anchor="t" lIns="0" tIns="0" rIns="0" bIns="0">
+            <a:spAutoFit/>
+          </a:bodyPr>
+          <a:lstStyle/>
+          <a:p>
+            <a:pPr algn="l">
+              <a:spcAft>
+                <a:spcPts val="0"/>
+              </a:spcAft>
+            </a:pPr>
+            <a:r>
+              <a:rPr sz="1800" b="0">
+                <a:solidFill>
+                  <a:srgbClr val="374151"/>
+                </a:solidFill>
+                <a:latin typeface="Arial"/>
+                <a:ea typeface="Arial"/>
+                <a:cs typeface="Arial"/>
+              </a:rPr>
+              <a:t>Try it, read the code, watch the demo</a:t>
+            </a:r>
+          </a:p>
+        </p:txBody>
+      </p:sp>
+      <p:sp>
+        <p:nvSpPr>
+          <p:cNvPr id="6" name="Footer"/>
+          <p:cNvSpPr txBox="1"/>
+          <p:nvPr/>
+        </p:nvSpPr>
+        <p:spPr>
+          <a:xfrm>
+            <a:off x="640080" y="6400800"/>
+            <a:ext cx="7315200" cy="228600"/>
+          </a:xfrm>
+          <a:prstGeom prst="rect">
+            <a:avLst/>
+          </a:prstGeom>
+          <a:noFill/>
+        </p:spPr>
+        <p:txBody>
+          <a:bodyPr wrap="square" anchor="t" lIns="0" tIns="0" rIns="0" bIns="0">
+            <a:spAutoFit/>
+          </a:bodyPr>
+          <a:lstStyle/>
+          <a:p>
+            <a:pPr algn="l">
+              <a:spcAft>
+                <a:spcPts val="0"/>
+              </a:spcAft>
+            </a:pPr>
+            <a:r>
+              <a:rPr sz="1000" b="0">
+                <a:solidFill>
+                  <a:srgbClr val="6B7280"/>
+                </a:solidFill>
+                <a:latin typeface="Arial"/>
+                <a:ea typeface="Arial"/>
+                <a:cs typeface="Arial"/>
+              </a:rPr>
+              <a:t>Green Corridor · Links</a:t>
+            </a:r>
+          </a:p>
+        </p:txBody>
+      </p:sp>
+      <p:sp>
+        <p:nvSpPr>
+          <p:cNvPr id="7" name="Page"/>
+          <p:cNvSpPr txBox="1"/>
+          <p:nvPr/>
+        </p:nvSpPr>
+        <p:spPr>
+          <a:xfrm>
+            <a:off x="9722815" y="6400800"/>
+            <a:ext cx="1828800" cy="228600"/>
+          </a:xfrm>
+          <a:prstGeom prst="rect">
+            <a:avLst/>
+          </a:prstGeom>
+          <a:noFill/>
+        </p:spPr>
+        <p:txBody>
+          <a:bodyPr wrap="square" anchor="t" lIns="0" tIns="0" rIns="0" bIns="0">
+            <a:spAutoFit/>
+          </a:bodyPr>
+          <a:lstStyle/>
+          <a:p>
+            <a:pPr algn="r">
+              <a:spcAft>
+                <a:spcPts val="0"/>
+              </a:spcAft>
+            </a:pPr>
+            <a:r>
+              <a:rPr sz="1000" b="0">
+                <a:solidFill>
+                  <a:srgbClr val="6B7280"/>
+                </a:solidFill>
+                <a:latin typeface="Arial"/>
+                <a:ea typeface="Arial"/>
+                <a:cs typeface="Arial"/>
+              </a:rPr>
+              <a:t>16 / 17</a:t>
             </a:r>
           </a:p>
         </p:txBody>
@@ -7936,7 +8504,7 @@
 </p:sld>
 </file>
 
-<file path=ppt/slides/slide16.xml><?xml version="1.0" encoding="utf-8"?>
+<file path=ppt/slides/slide17.xml><?xml version="1.0" encoding="utf-8"?>
 <p:sld xmlns:a="http://schemas.openxmlformats.org/drawingml/2006/main" xmlns:p="http://schemas.openxmlformats.org/presentationml/2006/main" xmlns:r="http://schemas.openxmlformats.org/officeDocument/2006/relationships">
   <p:cSld>
     <p:bg>
@@ -8267,7 +8835,7 @@
                 <a:ea typeface="Arial"/>
                 <a:cs typeface="Arial"/>
               </a:rPr>
-              <a:t>16 / 16</a:t>
+              <a:t>17 / 17</a:t>
             </a:r>
           </a:p>
         </p:txBody>
@@ -8534,7 +9102,7 @@
                 <a:ea typeface="Arial"/>
                 <a:cs typeface="Arial"/>
               </a:rPr>
-              <a:t>2 / 16</a:t>
+              <a:t>2 / 17</a:t>
             </a:r>
           </a:p>
         </p:txBody>
@@ -9313,7 +9881,7 @@
                 <a:ea typeface="Arial"/>
                 <a:cs typeface="Arial"/>
               </a:rPr>
-              <a:t>3 / 16</a:t>
+              <a:t>3 / 17</a:t>
             </a:r>
           </a:p>
         </p:txBody>
@@ -9902,7 +10470,7 @@
                 <a:ea typeface="Arial"/>
                 <a:cs typeface="Arial"/>
               </a:rPr>
-              <a:t>4 / 16</a:t>
+              <a:t>4 / 17</a:t>
             </a:r>
           </a:p>
         </p:txBody>
@@ -10929,7 +11497,7 @@
                 <a:ea typeface="Arial"/>
                 <a:cs typeface="Arial"/>
               </a:rPr>
-              <a:t>5 / 16</a:t>
+              <a:t>5 / 17</a:t>
             </a:r>
           </a:p>
         </p:txBody>
@@ -12312,7 +12880,7 @@
                 <a:ea typeface="Arial"/>
                 <a:cs typeface="Arial"/>
               </a:rPr>
-              <a:t>6 / 16</a:t>
+              <a:t>6 / 17</a:t>
             </a:r>
           </a:p>
         </p:txBody>
@@ -13619,7 +14187,7 @@
                 <a:ea typeface="Arial"/>
                 <a:cs typeface="Arial"/>
               </a:rPr>
-              <a:t>7 / 16</a:t>
+              <a:t>7 / 17</a:t>
             </a:r>
           </a:p>
         </p:txBody>
@@ -14330,7 +14898,7 @@
                 <a:ea typeface="Arial"/>
                 <a:cs typeface="Arial"/>
               </a:rPr>
-              <a:t>8 / 16</a:t>
+              <a:t>8 / 17</a:t>
             </a:r>
           </a:p>
         </p:txBody>
@@ -14673,7 +15241,7 @@
                 <a:ea typeface="Arial"/>
                 <a:cs typeface="Arial"/>
               </a:rPr>
-              <a:t>9 / 16</a:t>
+              <a:t>9 / 17</a:t>
             </a:r>
           </a:p>
         </p:txBody>
@@ -15844,7 +16412,7 @@
                 <a:ea typeface="Arial"/>
                 <a:cs typeface="Arial"/>
               </a:rPr>
-              <a:t>pipeline in place; model retrained on peak rows before submission</a:t>
+              <a:t>pipeline in place; peak-hour spans logging on Cloud Scheduler since 6 Oct; model retrained before submission</a:t>
             </a:r>
           </a:p>
         </p:txBody>

</xml_diff>

<commit_message>
docs: add re-planner to Gemini uses, correct sequencing and timeout notes, refresh deck
</commit_message>
<xml_diff>
--- a/deck/Green-Corridor-Deck.pptx
+++ b/deck/Green-Corridor-Deck.pptx
@@ -6286,7 +6286,7 @@
                 <a:ea typeface="Arial"/>
                 <a:cs typeface="Arial"/>
               </a:rPr>
-              <a:t>349</a:t>
+              <a:t>412</a:t>
             </a:r>
             <a:r>
               <a:rPr sz="1800" b="0">
@@ -6308,7 +6308,7 @@
                 <a:ea typeface="Arial"/>
                 <a:cs typeface="Arial"/>
               </a:rPr>
-              <a:t>147</a:t>
+              <a:t>161</a:t>
             </a:r>
             <a:r>
               <a:rPr sz="1800" b="0">

</xml_diff>

<commit_message>
data: retrain jam forecast on peak-hour rows and fill traffic counts
</commit_message>
<xml_diff>
--- a/deck/Green-Corridor-Deck.pptx
+++ b/deck/Green-Corridor-Deck.pptx
@@ -6997,7 +6997,7 @@
                 <a:ea typeface="Arial"/>
                 <a:cs typeface="Arial"/>
               </a:rPr>
-              <a:t>Peak-hour spans already logged.</a:t>
+              <a:t>2,173 traffic readings logged, 5–8 Oct.</a:t>
             </a:r>
           </a:p>
         </p:txBody>
@@ -16412,7 +16412,7 @@
                 <a:ea typeface="Arial"/>
                 <a:cs typeface="Arial"/>
               </a:rPr>
-              <a:t>pipeline in place; peak-hour spans logging on Cloud Scheduler since 6 Oct; model retrained before submission</a:t>
+              <a:t>retrained 8 Oct on 2,173 traffic readings, 5–8 Oct, mostly peak hours; 88% still zero jam; baseline, not deployed</a:t>
             </a:r>
           </a:p>
         </p:txBody>

</xml_diff>